<commit_message>
Add 3 seminar summary slides with concept diagrams
Slides 9-11: 2026 AI자율제조혁신 컨퍼런스 (벡스코, 7/1~7/2)
- Slide 9: 픽킷코리아 — AI 3D Vision 빈피킹 자율제조 (Day1)
- Slide 10: 뉴로클 — AI 오토딥러닝 비전검사 성공사례 (Day1)
- Slide 11: FARO Creaform — 자동화 3D 측정 품질혁신 (Day2)
Each slide includes process concept diagram + LG 시사점.

Co-Authored-By: Claude Sonnet 4.6 <noreply@anthropic.com>
Claude-Session: https://claude.ai/code/session_011bgHwR9e2obrur1dxJgtTR
</commit_message>
<xml_diff>
--- a/roboexpo_2026_관람보고서_LG생산기술원.pptx
+++ b/roboexpo_2026_관람보고서_LG생산기술원.pptx
@@ -13,6 +13,9 @@
     <p:sldId id="261" r:id="rId12"/>
     <p:sldId id="262" r:id="rId13"/>
     <p:sldId id="263" r:id="rId14"/>
+    <p:sldId id="264" r:id="rId15"/>
+    <p:sldId id="265" r:id="rId16"/>
+    <p:sldId id="266" r:id="rId17"/>
   </p:sldIdLst>
   <p:sldSz cx="12188952" cy="6858000" type="screen4x3"/>
   <p:notesSz cx="6858000" cy="9144000"/>
@@ -4005,6 +4008,2150 @@
 </p:sld>
 </file>
 
+<file path=ppt/slides/slide10.xml><?xml version="1.0" encoding="utf-8"?>
+<p:sld xmlns:a="http://schemas.openxmlformats.org/drawingml/2006/main" xmlns:p="http://schemas.openxmlformats.org/presentationml/2006/main" xmlns:r="http://schemas.openxmlformats.org/officeDocument/2006/relationships">
+  <p:cSld>
+    <p:spTree>
+      <p:nvGrpSpPr>
+        <p:cNvPr id="1" name=""/>
+        <p:cNvGrpSpPr/>
+        <p:nvPr/>
+      </p:nvGrpSpPr>
+      <p:grpSpPr/>
+      <p:sp>
+        <p:nvSpPr>
+          <p:cNvPr id="2" name="Rectangle 1"/>
+          <p:cNvSpPr/>
+          <p:nvPr/>
+        </p:nvSpPr>
+        <p:spPr>
+          <a:xfrm>
+            <a:off x="0" y="0"/>
+            <a:ext cx="12188952" cy="6858000"/>
+          </a:xfrm>
+          <a:prstGeom prst="rect">
+            <a:avLst/>
+          </a:prstGeom>
+          <a:solidFill>
+            <a:srgbClr val="FFFFFF"/>
+          </a:solidFill>
+          <a:ln>
+            <a:noFill/>
+          </a:ln>
+        </p:spPr>
+        <p:style>
+          <a:lnRef idx="1">
+            <a:schemeClr val="accent1"/>
+          </a:lnRef>
+          <a:fillRef idx="3">
+            <a:schemeClr val="accent1"/>
+          </a:fillRef>
+          <a:effectRef idx="2">
+            <a:schemeClr val="accent1"/>
+          </a:effectRef>
+          <a:fontRef idx="minor">
+            <a:schemeClr val="lt1"/>
+          </a:fontRef>
+        </p:style>
+        <p:txBody>
+          <a:bodyPr rtlCol="0" anchor="ctr"/>
+          <a:lstStyle/>
+          <a:p>
+            <a:pPr algn="ctr"/>
+          </a:p>
+        </p:txBody>
+      </p:sp>
+      <p:sp>
+        <p:nvSpPr>
+          <p:cNvPr id="3" name="Rectangle 2"/>
+          <p:cNvSpPr/>
+          <p:nvPr/>
+        </p:nvSpPr>
+        <p:spPr>
+          <a:xfrm>
+            <a:off x="0" y="0"/>
+            <a:ext cx="12188952" cy="914400"/>
+          </a:xfrm>
+          <a:prstGeom prst="rect">
+            <a:avLst/>
+          </a:prstGeom>
+          <a:solidFill>
+            <a:srgbClr val="1A2E4A"/>
+          </a:solidFill>
+          <a:ln>
+            <a:noFill/>
+          </a:ln>
+        </p:spPr>
+        <p:style>
+          <a:lnRef idx="1">
+            <a:schemeClr val="accent1"/>
+          </a:lnRef>
+          <a:fillRef idx="3">
+            <a:schemeClr val="accent1"/>
+          </a:fillRef>
+          <a:effectRef idx="2">
+            <a:schemeClr val="accent1"/>
+          </a:effectRef>
+          <a:fontRef idx="minor">
+            <a:schemeClr val="lt1"/>
+          </a:fontRef>
+        </p:style>
+        <p:txBody>
+          <a:bodyPr rtlCol="0" anchor="ctr"/>
+          <a:lstStyle/>
+          <a:p>
+            <a:pPr algn="ctr"/>
+          </a:p>
+        </p:txBody>
+      </p:sp>
+      <p:sp>
+        <p:nvSpPr>
+          <p:cNvPr id="4" name="Rectangle 3"/>
+          <p:cNvSpPr/>
+          <p:nvPr/>
+        </p:nvSpPr>
+        <p:spPr>
+          <a:xfrm>
+            <a:off x="0" y="0"/>
+            <a:ext cx="73152" cy="914400"/>
+          </a:xfrm>
+          <a:prstGeom prst="rect">
+            <a:avLst/>
+          </a:prstGeom>
+          <a:solidFill>
+            <a:srgbClr val="CE0A2C"/>
+          </a:solidFill>
+          <a:ln>
+            <a:noFill/>
+          </a:ln>
+        </p:spPr>
+        <p:style>
+          <a:lnRef idx="1">
+            <a:schemeClr val="accent1"/>
+          </a:lnRef>
+          <a:fillRef idx="3">
+            <a:schemeClr val="accent1"/>
+          </a:fillRef>
+          <a:effectRef idx="2">
+            <a:schemeClr val="accent1"/>
+          </a:effectRef>
+          <a:fontRef idx="minor">
+            <a:schemeClr val="lt1"/>
+          </a:fontRef>
+        </p:style>
+        <p:txBody>
+          <a:bodyPr rtlCol="0" anchor="ctr"/>
+          <a:lstStyle/>
+          <a:p>
+            <a:pPr algn="ctr"/>
+          </a:p>
+        </p:txBody>
+      </p:sp>
+      <p:sp>
+        <p:nvSpPr>
+          <p:cNvPr id="5" name="TextBox 4"/>
+          <p:cNvSpPr txBox="1"/>
+          <p:nvPr/>
+        </p:nvSpPr>
+        <p:spPr>
+          <a:xfrm>
+            <a:off x="228600" y="73152"/>
+            <a:ext cx="11155680" cy="566928"/>
+          </a:xfrm>
+          <a:prstGeom prst="rect">
+            <a:avLst/>
+          </a:prstGeom>
+          <a:noFill/>
+        </p:spPr>
+        <p:txBody>
+          <a:bodyPr wrap="square">
+            <a:spAutoFit/>
+          </a:bodyPr>
+          <a:lstStyle/>
+          <a:p>
+            <a:pPr algn="l"/>
+            <a:r>
+              <a:rPr sz="2200" b="1">
+                <a:solidFill>
+                  <a:srgbClr val="FFFFFF"/>
+                </a:solidFill>
+                <a:latin typeface="맑은 고딕"/>
+              </a:rPr>
+              <a:t>[세미나②] AI 오토딥러닝 비전검사 성공사례 — 뉴로클</a:t>
+            </a:r>
+          </a:p>
+        </p:txBody>
+      </p:sp>
+      <p:sp>
+        <p:nvSpPr>
+          <p:cNvPr id="6" name="TextBox 5"/>
+          <p:cNvSpPr txBox="1"/>
+          <p:nvPr/>
+        </p:nvSpPr>
+        <p:spPr>
+          <a:xfrm>
+            <a:off x="228600" y="621792"/>
+            <a:ext cx="11430000" cy="274320"/>
+          </a:xfrm>
+          <a:prstGeom prst="rect">
+            <a:avLst/>
+          </a:prstGeom>
+          <a:noFill/>
+        </p:spPr>
+        <p:txBody>
+          <a:bodyPr wrap="square">
+            <a:spAutoFit/>
+          </a:bodyPr>
+          <a:lstStyle/>
+          <a:p>
+            <a:pPr algn="l"/>
+            <a:r>
+              <a:rPr sz="1100" b="0">
+                <a:solidFill>
+                  <a:srgbClr val="FF4C5C"/>
+                </a:solidFill>
+                <a:latin typeface="맑은 고딕"/>
+              </a:rPr>
+              <a:t>2026 AI자율제조혁신 컨퍼런스  |  Day 1 (7/1)  15:00~15:30  |  벡스코 제2전시장 4홀 컨퍼런스룸  |  분야: 자동차·철강 인라인 품질검사</a:t>
+            </a:r>
+          </a:p>
+        </p:txBody>
+      </p:sp>
+      <p:sp>
+        <p:nvSpPr>
+          <p:cNvPr id="7" name="Rectangle 6"/>
+          <p:cNvSpPr/>
+          <p:nvPr/>
+        </p:nvSpPr>
+        <p:spPr>
+          <a:xfrm>
+            <a:off x="0" y="6583680"/>
+            <a:ext cx="12188952" cy="274320"/>
+          </a:xfrm>
+          <a:prstGeom prst="rect">
+            <a:avLst/>
+          </a:prstGeom>
+          <a:solidFill>
+            <a:srgbClr val="1A2E4A"/>
+          </a:solidFill>
+          <a:ln>
+            <a:noFill/>
+          </a:ln>
+        </p:spPr>
+        <p:style>
+          <a:lnRef idx="1">
+            <a:schemeClr val="accent1"/>
+          </a:lnRef>
+          <a:fillRef idx="3">
+            <a:schemeClr val="accent1"/>
+          </a:fillRef>
+          <a:effectRef idx="2">
+            <a:schemeClr val="accent1"/>
+          </a:effectRef>
+          <a:fontRef idx="minor">
+            <a:schemeClr val="lt1"/>
+          </a:fontRef>
+        </p:style>
+        <p:txBody>
+          <a:bodyPr rtlCol="0" anchor="ctr"/>
+          <a:lstStyle/>
+          <a:p>
+            <a:pPr algn="ctr"/>
+          </a:p>
+        </p:txBody>
+      </p:sp>
+      <p:sp>
+        <p:nvSpPr>
+          <p:cNvPr id="8" name="TextBox 7"/>
+          <p:cNvSpPr txBox="1"/>
+          <p:nvPr/>
+        </p:nvSpPr>
+        <p:spPr>
+          <a:xfrm>
+            <a:off x="182880" y="6601968"/>
+            <a:ext cx="8229600" cy="228600"/>
+          </a:xfrm>
+          <a:prstGeom prst="rect">
+            <a:avLst/>
+          </a:prstGeom>
+          <a:noFill/>
+        </p:spPr>
+        <p:txBody>
+          <a:bodyPr wrap="square">
+            <a:spAutoFit/>
+          </a:bodyPr>
+          <a:lstStyle/>
+          <a:p>
+            <a:pPr algn="l"/>
+            <a:r>
+              <a:rPr sz="1000" b="0">
+                <a:solidFill>
+                  <a:srgbClr val="FFFFFF"/>
+                </a:solidFill>
+                <a:latin typeface="맑은 고딕"/>
+              </a:rPr>
+              <a:t>LG전자 생산기술원  |  2026 부산로봇엑스포 관람 보고서</a:t>
+            </a:r>
+          </a:p>
+        </p:txBody>
+      </p:sp>
+      <p:sp>
+        <p:nvSpPr>
+          <p:cNvPr id="9" name="TextBox 8"/>
+          <p:cNvSpPr txBox="1"/>
+          <p:nvPr/>
+        </p:nvSpPr>
+        <p:spPr>
+          <a:xfrm>
+            <a:off x="10972800" y="6601968"/>
+            <a:ext cx="1097280" cy="228600"/>
+          </a:xfrm>
+          <a:prstGeom prst="rect">
+            <a:avLst/>
+          </a:prstGeom>
+          <a:noFill/>
+        </p:spPr>
+        <p:txBody>
+          <a:bodyPr wrap="square">
+            <a:spAutoFit/>
+          </a:bodyPr>
+          <a:lstStyle/>
+          <a:p>
+            <a:pPr algn="r"/>
+            <a:r>
+              <a:rPr sz="1000" b="0">
+                <a:solidFill>
+                  <a:srgbClr val="FFFFFF"/>
+                </a:solidFill>
+                <a:latin typeface="맑은 고딕"/>
+              </a:rPr>
+              <a:t>2026. 7. 3.</a:t>
+            </a:r>
+          </a:p>
+        </p:txBody>
+      </p:sp>
+      <p:sp>
+        <p:nvSpPr>
+          <p:cNvPr id="10" name="Rectangle 9"/>
+          <p:cNvSpPr/>
+          <p:nvPr/>
+        </p:nvSpPr>
+        <p:spPr>
+          <a:xfrm>
+            <a:off x="228600" y="1005840"/>
+            <a:ext cx="6812280" cy="5440680"/>
+          </a:xfrm>
+          <a:prstGeom prst="rect">
+            <a:avLst/>
+          </a:prstGeom>
+          <a:solidFill>
+            <a:srgbClr val="F2F2F2"/>
+          </a:solidFill>
+          <a:ln>
+            <a:noFill/>
+          </a:ln>
+        </p:spPr>
+        <p:style>
+          <a:lnRef idx="1">
+            <a:schemeClr val="accent1"/>
+          </a:lnRef>
+          <a:fillRef idx="3">
+            <a:schemeClr val="accent1"/>
+          </a:fillRef>
+          <a:effectRef idx="2">
+            <a:schemeClr val="accent1"/>
+          </a:effectRef>
+          <a:fontRef idx="minor">
+            <a:schemeClr val="lt1"/>
+          </a:fontRef>
+        </p:style>
+        <p:txBody>
+          <a:bodyPr rtlCol="0" anchor="ctr"/>
+          <a:lstStyle/>
+          <a:p>
+            <a:pPr algn="ctr"/>
+          </a:p>
+        </p:txBody>
+      </p:sp>
+      <p:sp>
+        <p:nvSpPr>
+          <p:cNvPr id="11" name="Rectangle 10"/>
+          <p:cNvSpPr/>
+          <p:nvPr/>
+        </p:nvSpPr>
+        <p:spPr>
+          <a:xfrm>
+            <a:off x="228600" y="1005840"/>
+            <a:ext cx="6812280" cy="384048"/>
+          </a:xfrm>
+          <a:prstGeom prst="rect">
+            <a:avLst/>
+          </a:prstGeom>
+          <a:solidFill>
+            <a:srgbClr val="1A2E4A"/>
+          </a:solidFill>
+          <a:ln>
+            <a:noFill/>
+          </a:ln>
+        </p:spPr>
+        <p:style>
+          <a:lnRef idx="1">
+            <a:schemeClr val="accent1"/>
+          </a:lnRef>
+          <a:fillRef idx="3">
+            <a:schemeClr val="accent1"/>
+          </a:fillRef>
+          <a:effectRef idx="2">
+            <a:schemeClr val="accent1"/>
+          </a:effectRef>
+          <a:fontRef idx="minor">
+            <a:schemeClr val="lt1"/>
+          </a:fontRef>
+        </p:style>
+        <p:txBody>
+          <a:bodyPr rtlCol="0" anchor="ctr"/>
+          <a:lstStyle/>
+          <a:p>
+            <a:pPr algn="ctr"/>
+          </a:p>
+        </p:txBody>
+      </p:sp>
+      <p:sp>
+        <p:nvSpPr>
+          <p:cNvPr id="12" name="TextBox 11"/>
+          <p:cNvSpPr txBox="1"/>
+          <p:nvPr/>
+        </p:nvSpPr>
+        <p:spPr>
+          <a:xfrm>
+            <a:off x="228600" y="1005840"/>
+            <a:ext cx="6812280" cy="384048"/>
+          </a:xfrm>
+          <a:prstGeom prst="rect">
+            <a:avLst/>
+          </a:prstGeom>
+          <a:noFill/>
+        </p:spPr>
+        <p:txBody>
+          <a:bodyPr wrap="square">
+            <a:spAutoFit/>
+          </a:bodyPr>
+          <a:lstStyle/>
+          <a:p>
+            <a:pPr algn="ctr"/>
+            <a:r>
+              <a:rPr sz="1200" b="1">
+                <a:solidFill>
+                  <a:srgbClr val="FFFFFF"/>
+                </a:solidFill>
+                <a:latin typeface="맑은 고딕"/>
+              </a:rPr>
+              <a:t>뉴로클 (Neuro-Clone)  —  발표 내용 요약</a:t>
+            </a:r>
+          </a:p>
+        </p:txBody>
+      </p:sp>
+      <p:sp>
+        <p:nvSpPr>
+          <p:cNvPr id="13" name="TextBox 12"/>
+          <p:cNvSpPr txBox="1"/>
+          <p:nvPr/>
+        </p:nvSpPr>
+        <p:spPr>
+          <a:xfrm>
+            <a:off x="347472" y="1444752"/>
+            <a:ext cx="6583680" cy="274320"/>
+          </a:xfrm>
+          <a:prstGeom prst="rect">
+            <a:avLst/>
+          </a:prstGeom>
+          <a:noFill/>
+        </p:spPr>
+        <p:txBody>
+          <a:bodyPr wrap="square">
+            <a:spAutoFit/>
+          </a:bodyPr>
+          <a:lstStyle/>
+          <a:p>
+            <a:pPr algn="l"/>
+            <a:r>
+              <a:rPr sz="1200" b="1">
+                <a:solidFill>
+                  <a:srgbClr val="1A2E4A"/>
+                </a:solidFill>
+                <a:latin typeface="맑은 고딕"/>
+              </a:rPr>
+              <a:t>■ 발표 주제</a:t>
+            </a:r>
+          </a:p>
+        </p:txBody>
+      </p:sp>
+      <p:sp>
+        <p:nvSpPr>
+          <p:cNvPr id="14" name="TextBox 13"/>
+          <p:cNvSpPr txBox="1"/>
+          <p:nvPr/>
+        </p:nvSpPr>
+        <p:spPr>
+          <a:xfrm>
+            <a:off x="347472" y="1719072"/>
+            <a:ext cx="6583680" cy="274320"/>
+          </a:xfrm>
+          <a:prstGeom prst="rect">
+            <a:avLst/>
+          </a:prstGeom>
+          <a:noFill/>
+        </p:spPr>
+        <p:txBody>
+          <a:bodyPr wrap="square">
+            <a:spAutoFit/>
+          </a:bodyPr>
+          <a:lstStyle/>
+          <a:p>
+            <a:pPr algn="l"/>
+            <a:r>
+              <a:rPr sz="1200" b="0">
+                <a:solidFill>
+                  <a:srgbClr val="1A1A1A"/>
+                </a:solidFill>
+                <a:latin typeface="맑은 고딕"/>
+              </a:rPr>
+              <a:t>AI 오토딥러닝 비전검사 솔루션 도입 성공 사례 (자동차·철강 분야)</a:t>
+            </a:r>
+          </a:p>
+        </p:txBody>
+      </p:sp>
+      <p:sp>
+        <p:nvSpPr>
+          <p:cNvPr id="15" name="TextBox 14"/>
+          <p:cNvSpPr txBox="1"/>
+          <p:nvPr/>
+        </p:nvSpPr>
+        <p:spPr>
+          <a:xfrm>
+            <a:off x="347472" y="2066543"/>
+            <a:ext cx="6583680" cy="274320"/>
+          </a:xfrm>
+          <a:prstGeom prst="rect">
+            <a:avLst/>
+          </a:prstGeom>
+          <a:noFill/>
+        </p:spPr>
+        <p:txBody>
+          <a:bodyPr wrap="square">
+            <a:spAutoFit/>
+          </a:bodyPr>
+          <a:lstStyle/>
+          <a:p>
+            <a:pPr algn="l"/>
+            <a:r>
+              <a:rPr sz="1200" b="1">
+                <a:solidFill>
+                  <a:srgbClr val="1A2E4A"/>
+                </a:solidFill>
+                <a:latin typeface="맑은 고딕"/>
+              </a:rPr>
+              <a:t>■ 핵심 발표 내용</a:t>
+            </a:r>
+          </a:p>
+        </p:txBody>
+      </p:sp>
+      <p:sp>
+        <p:nvSpPr>
+          <p:cNvPr id="16" name="TextBox 15"/>
+          <p:cNvSpPr txBox="1"/>
+          <p:nvPr/>
+        </p:nvSpPr>
+        <p:spPr>
+          <a:xfrm>
+            <a:off x="347472" y="2377440"/>
+            <a:ext cx="6583680" cy="1828800"/>
+          </a:xfrm>
+          <a:prstGeom prst="rect">
+            <a:avLst/>
+          </a:prstGeom>
+          <a:noFill/>
+        </p:spPr>
+        <p:txBody>
+          <a:bodyPr wrap="square">
+            <a:spAutoFit/>
+          </a:bodyPr>
+          <a:lstStyle/>
+          <a:p>
+            <a:pPr algn="l">
+              <a:spcAft>
+                <a:spcPts val="200"/>
+              </a:spcAft>
+            </a:pPr>
+            <a:r>
+              <a:rPr sz="1150" b="0">
+                <a:solidFill>
+                  <a:srgbClr val="1A1A1A"/>
+                </a:solidFill>
+                <a:latin typeface="맑은 고딕"/>
+              </a:rPr>
+              <a:t>• 오토딥러닝: 소수 불량 이미지(10장 이내)로 AI 검사 모델 자동 생성 — 데이터사이언티스트 불필요</a:t>
+            </a:r>
+          </a:p>
+          <a:p>
+            <a:pPr algn="l">
+              <a:spcAft>
+                <a:spcPts val="200"/>
+              </a:spcAft>
+            </a:pPr>
+            <a:r>
+              <a:rPr sz="1150" b="0">
+                <a:solidFill>
+                  <a:srgbClr val="1A1A1A"/>
+                </a:solidFill>
+                <a:latin typeface="맑은 고딕"/>
+              </a:rPr>
+              <a:t>• 자동차 분야: 차체 도장 핀홀·긁힘 결함, 용접 비드 기공 인라인 실시간 검출 사례 발표</a:t>
+            </a:r>
+          </a:p>
+          <a:p>
+            <a:pPr algn="l">
+              <a:spcAft>
+                <a:spcPts val="200"/>
+              </a:spcAft>
+            </a:pPr>
+            <a:r>
+              <a:rPr sz="1150" b="0">
+                <a:solidFill>
+                  <a:srgbClr val="1A1A1A"/>
+                </a:solidFill>
+                <a:latin typeface="맑은 고딕"/>
+              </a:rPr>
+              <a:t>• 철강 분야: 열연·냉연 코일 표면 스크래치·기포·압흔 AI 자동 분류 및 등급 자동 판정</a:t>
+            </a:r>
+          </a:p>
+          <a:p>
+            <a:pPr algn="l">
+              <a:spcAft>
+                <a:spcPts val="200"/>
+              </a:spcAft>
+            </a:pPr>
+            <a:r>
+              <a:rPr sz="1150" b="0">
+                <a:solidFill>
+                  <a:srgbClr val="1A1A1A"/>
+                </a:solidFill>
+                <a:latin typeface="맑은 고딕"/>
+              </a:rPr>
+              <a:t>• 성능 지표: 검사 정확도 99% 이상 | 인라인 처리 속도 0.3~0.5초/개 | 오검출률 0.2% 미만</a:t>
+            </a:r>
+          </a:p>
+          <a:p>
+            <a:pPr algn="l">
+              <a:spcAft>
+                <a:spcPts val="200"/>
+              </a:spcAft>
+            </a:pPr>
+            <a:r>
+              <a:rPr sz="1150" b="0">
+                <a:solidFill>
+                  <a:srgbClr val="1A1A1A"/>
+                </a:solidFill>
+                <a:latin typeface="맑은 고딕"/>
+              </a:rPr>
+              <a:t>• SaaS 구독 방식: 초기 설비 투자 없이 월 사용료 기반 운영 — 중소기업도 즉시 도입 가능</a:t>
+            </a:r>
+          </a:p>
+          <a:p>
+            <a:pPr algn="l">
+              <a:spcAft>
+                <a:spcPts val="200"/>
+              </a:spcAft>
+            </a:pPr>
+            <a:r>
+              <a:rPr sz="1150" b="0">
+                <a:solidFill>
+                  <a:srgbClr val="1A1A1A"/>
+                </a:solidFill>
+                <a:latin typeface="맑은 고딕"/>
+              </a:rPr>
+              <a:t>• 전주기 오토딥러닝: 검사 설계 → 모델 학습 → 배포 → 재학습까지 자동화 완성</a:t>
+            </a:r>
+          </a:p>
+        </p:txBody>
+      </p:sp>
+      <p:sp>
+        <p:nvSpPr>
+          <p:cNvPr id="17" name="Rectangle 16"/>
+          <p:cNvSpPr/>
+          <p:nvPr/>
+        </p:nvSpPr>
+        <p:spPr>
+          <a:xfrm>
+            <a:off x="347472" y="4251960"/>
+            <a:ext cx="6583680" cy="27432"/>
+          </a:xfrm>
+          <a:prstGeom prst="rect">
+            <a:avLst/>
+          </a:prstGeom>
+          <a:solidFill>
+            <a:srgbClr val="CE0A2C"/>
+          </a:solidFill>
+          <a:ln>
+            <a:noFill/>
+          </a:ln>
+        </p:spPr>
+        <p:style>
+          <a:lnRef idx="1">
+            <a:schemeClr val="accent1"/>
+          </a:lnRef>
+          <a:fillRef idx="3">
+            <a:schemeClr val="accent1"/>
+          </a:fillRef>
+          <a:effectRef idx="2">
+            <a:schemeClr val="accent1"/>
+          </a:effectRef>
+          <a:fontRef idx="minor">
+            <a:schemeClr val="lt1"/>
+          </a:fontRef>
+        </p:style>
+        <p:txBody>
+          <a:bodyPr rtlCol="0" anchor="ctr"/>
+          <a:lstStyle/>
+          <a:p>
+            <a:pPr algn="ctr"/>
+          </a:p>
+        </p:txBody>
+      </p:sp>
+      <p:sp>
+        <p:nvSpPr>
+          <p:cNvPr id="18" name="TextBox 17"/>
+          <p:cNvSpPr txBox="1"/>
+          <p:nvPr/>
+        </p:nvSpPr>
+        <p:spPr>
+          <a:xfrm>
+            <a:off x="347472" y="4315968"/>
+            <a:ext cx="6583680" cy="274320"/>
+          </a:xfrm>
+          <a:prstGeom prst="rect">
+            <a:avLst/>
+          </a:prstGeom>
+          <a:noFill/>
+        </p:spPr>
+        <p:txBody>
+          <a:bodyPr wrap="square">
+            <a:spAutoFit/>
+          </a:bodyPr>
+          <a:lstStyle/>
+          <a:p>
+            <a:pPr algn="l"/>
+            <a:r>
+              <a:rPr sz="1200" b="1">
+                <a:solidFill>
+                  <a:srgbClr val="CE0A2C"/>
+                </a:solidFill>
+                <a:latin typeface="맑은 고딕"/>
+              </a:rPr>
+              <a:t>■ LG생산기술원 시사점</a:t>
+            </a:r>
+          </a:p>
+        </p:txBody>
+      </p:sp>
+      <p:sp>
+        <p:nvSpPr>
+          <p:cNvPr id="19" name="TextBox 18"/>
+          <p:cNvSpPr txBox="1"/>
+          <p:nvPr/>
+        </p:nvSpPr>
+        <p:spPr>
+          <a:xfrm>
+            <a:off x="347472" y="4645152"/>
+            <a:ext cx="6583680" cy="868680"/>
+          </a:xfrm>
+          <a:prstGeom prst="rect">
+            <a:avLst/>
+          </a:prstGeom>
+          <a:noFill/>
+        </p:spPr>
+        <p:txBody>
+          <a:bodyPr wrap="square">
+            <a:spAutoFit/>
+          </a:bodyPr>
+          <a:lstStyle/>
+          <a:p>
+            <a:pPr algn="l">
+              <a:spcAft>
+                <a:spcPts val="200"/>
+              </a:spcAft>
+            </a:pPr>
+            <a:r>
+              <a:rPr sz="1100" b="0">
+                <a:solidFill>
+                  <a:srgbClr val="1A1A1A"/>
+                </a:solidFill>
+                <a:latin typeface="맑은 고딕"/>
+              </a:rPr>
+              <a:t>▶ 가전 외장재(세탁기·냉장고 메탈 패널) 외관 불량 검사에 즉시 적용 가능 — 공급업체 PoC 착수</a:t>
+            </a:r>
+          </a:p>
+          <a:p>
+            <a:pPr algn="l">
+              <a:spcAft>
+                <a:spcPts val="200"/>
+              </a:spcAft>
+            </a:pPr>
+            <a:r>
+              <a:rPr sz="1100" b="0">
+                <a:solidFill>
+                  <a:srgbClr val="1A1A1A"/>
+                </a:solidFill>
+                <a:latin typeface="맑은 고딕"/>
+              </a:rPr>
+              <a:t>▶ 소수 이미지 학습 → 신제품 출시 시 QC 모델 구축 기간 3개월 → 1주 이내로 단축 가능</a:t>
+            </a:r>
+          </a:p>
+          <a:p>
+            <a:pPr algn="l">
+              <a:spcAft>
+                <a:spcPts val="200"/>
+              </a:spcAft>
+            </a:pPr>
+            <a:r>
+              <a:rPr sz="1100" b="0">
+                <a:solidFill>
+                  <a:srgbClr val="1A1A1A"/>
+                </a:solidFill>
+                <a:latin typeface="맑은 고딕"/>
+              </a:rPr>
+              <a:t>▶ SaaS 방식 시범 도입 후 전 라인 확대 전략 — 투자 리스크 최소화, 6개월 내 ROI 검증</a:t>
+            </a:r>
+          </a:p>
+        </p:txBody>
+      </p:sp>
+      <p:pic>
+        <p:nvPicPr>
+          <p:cNvPr id="20" name="Picture 19" descr="image.png"/>
+          <p:cNvPicPr>
+            <a:picLocks noChangeAspect="1"/>
+          </p:cNvPicPr>
+          <p:nvPr/>
+        </p:nvPicPr>
+        <p:blipFill>
+          <a:blip r:embed="rId2"/>
+          <a:stretch>
+            <a:fillRect/>
+          </a:stretch>
+        </p:blipFill>
+        <p:spPr>
+          <a:xfrm>
+            <a:off x="7223760" y="1005840"/>
+            <a:ext cx="4736592" cy="2926080"/>
+          </a:xfrm>
+          <a:prstGeom prst="rect">
+            <a:avLst/>
+          </a:prstGeom>
+        </p:spPr>
+      </p:pic>
+      <p:sp>
+        <p:nvSpPr>
+          <p:cNvPr id="21" name="TextBox 20"/>
+          <p:cNvSpPr txBox="1"/>
+          <p:nvPr/>
+        </p:nvSpPr>
+        <p:spPr>
+          <a:xfrm>
+            <a:off x="7223760" y="3977639"/>
+            <a:ext cx="4736592" cy="274320"/>
+          </a:xfrm>
+          <a:prstGeom prst="rect">
+            <a:avLst/>
+          </a:prstGeom>
+          <a:noFill/>
+        </p:spPr>
+        <p:txBody>
+          <a:bodyPr wrap="square">
+            <a:spAutoFit/>
+          </a:bodyPr>
+          <a:lstStyle/>
+          <a:p>
+            <a:pPr algn="ctr"/>
+            <a:r>
+              <a:rPr sz="950" b="0">
+                <a:solidFill>
+                  <a:srgbClr val="555555"/>
+                </a:solidFill>
+                <a:latin typeface="맑은 고딕"/>
+              </a:rPr>
+              <a:t>▲ 뉴로클 오토딥러닝 비전검사 프로세스 개념도</a:t>
+            </a:r>
+          </a:p>
+        </p:txBody>
+      </p:sp>
+      <p:sp>
+        <p:nvSpPr>
+          <p:cNvPr id="22" name="Rectangle 21"/>
+          <p:cNvSpPr/>
+          <p:nvPr/>
+        </p:nvSpPr>
+        <p:spPr>
+          <a:xfrm>
+            <a:off x="7223760" y="4251960"/>
+            <a:ext cx="4736592" cy="2121408"/>
+          </a:xfrm>
+          <a:prstGeom prst="rect">
+            <a:avLst/>
+          </a:prstGeom>
+          <a:solidFill>
+            <a:srgbClr val="F2F2F2"/>
+          </a:solidFill>
+          <a:ln>
+            <a:noFill/>
+          </a:ln>
+        </p:spPr>
+        <p:style>
+          <a:lnRef idx="1">
+            <a:schemeClr val="accent1"/>
+          </a:lnRef>
+          <a:fillRef idx="3">
+            <a:schemeClr val="accent1"/>
+          </a:fillRef>
+          <a:effectRef idx="2">
+            <a:schemeClr val="accent1"/>
+          </a:effectRef>
+          <a:fontRef idx="minor">
+            <a:schemeClr val="lt1"/>
+          </a:fontRef>
+        </p:style>
+        <p:txBody>
+          <a:bodyPr rtlCol="0" anchor="ctr"/>
+          <a:lstStyle/>
+          <a:p>
+            <a:pPr algn="ctr"/>
+          </a:p>
+        </p:txBody>
+      </p:sp>
+      <p:sp>
+        <p:nvSpPr>
+          <p:cNvPr id="23" name="Rectangle 22"/>
+          <p:cNvSpPr/>
+          <p:nvPr/>
+        </p:nvSpPr>
+        <p:spPr>
+          <a:xfrm>
+            <a:off x="7223760" y="4251960"/>
+            <a:ext cx="45720" cy="2121408"/>
+          </a:xfrm>
+          <a:prstGeom prst="rect">
+            <a:avLst/>
+          </a:prstGeom>
+          <a:solidFill>
+            <a:srgbClr val="1A2E4A"/>
+          </a:solidFill>
+          <a:ln>
+            <a:noFill/>
+          </a:ln>
+        </p:spPr>
+        <p:style>
+          <a:lnRef idx="1">
+            <a:schemeClr val="accent1"/>
+          </a:lnRef>
+          <a:fillRef idx="3">
+            <a:schemeClr val="accent1"/>
+          </a:fillRef>
+          <a:effectRef idx="2">
+            <a:schemeClr val="accent1"/>
+          </a:effectRef>
+          <a:fontRef idx="minor">
+            <a:schemeClr val="lt1"/>
+          </a:fontRef>
+        </p:style>
+        <p:txBody>
+          <a:bodyPr rtlCol="0" anchor="ctr"/>
+          <a:lstStyle/>
+          <a:p>
+            <a:pPr algn="ctr"/>
+          </a:p>
+        </p:txBody>
+      </p:sp>
+      <p:sp>
+        <p:nvSpPr>
+          <p:cNvPr id="24" name="TextBox 23"/>
+          <p:cNvSpPr txBox="1"/>
+          <p:nvPr/>
+        </p:nvSpPr>
+        <p:spPr>
+          <a:xfrm>
+            <a:off x="7315200" y="4297680"/>
+            <a:ext cx="4572000" cy="2011680"/>
+          </a:xfrm>
+          <a:prstGeom prst="rect">
+            <a:avLst/>
+          </a:prstGeom>
+          <a:noFill/>
+        </p:spPr>
+        <p:txBody>
+          <a:bodyPr wrap="square">
+            <a:spAutoFit/>
+          </a:bodyPr>
+          <a:lstStyle/>
+          <a:p>
+            <a:pPr algn="l">
+              <a:spcAft>
+                <a:spcPts val="200"/>
+              </a:spcAft>
+            </a:pPr>
+            <a:r>
+              <a:rPr sz="1100" b="0">
+                <a:solidFill>
+                  <a:srgbClr val="1A1A1A"/>
+                </a:solidFill>
+                <a:latin typeface="맑은 고딕"/>
+              </a:rPr>
+              <a:t>산업별 적용 성공 사례</a:t>
+            </a:r>
+          </a:p>
+          <a:p>
+            <a:pPr algn="l">
+              <a:spcAft>
+                <a:spcPts val="200"/>
+              </a:spcAft>
+            </a:pPr>
+            <a:r>
+              <a:rPr sz="1100" b="0">
+                <a:solidFill>
+                  <a:srgbClr val="1A1A1A"/>
+                </a:solidFill>
+                <a:latin typeface="맑은 고딕"/>
+              </a:rPr>
+              <a:t>• 자동차: 도장 불량 검사 (국내 완성차 OEM 라인 적용)</a:t>
+            </a:r>
+          </a:p>
+          <a:p>
+            <a:pPr algn="l">
+              <a:spcAft>
+                <a:spcPts val="200"/>
+              </a:spcAft>
+            </a:pPr>
+            <a:r>
+              <a:rPr sz="1100" b="0">
+                <a:solidFill>
+                  <a:srgbClr val="1A1A1A"/>
+                </a:solidFill>
+                <a:latin typeface="맑은 고딕"/>
+              </a:rPr>
+              <a:t>• 철강: 코일 표면 결함 자동 분류 등급 판정</a:t>
+            </a:r>
+          </a:p>
+          <a:p>
+            <a:pPr algn="l">
+              <a:spcAft>
+                <a:spcPts val="200"/>
+              </a:spcAft>
+            </a:pPr>
+            <a:r>
+              <a:rPr sz="1100" b="0">
+                <a:solidFill>
+                  <a:srgbClr val="1A1A1A"/>
+                </a:solidFill>
+                <a:latin typeface="맑은 고딕"/>
+              </a:rPr>
+              <a:t>• 전자: PCB 납땜 불량·크랙·이물 검사</a:t>
+            </a:r>
+          </a:p>
+          <a:p>
+            <a:pPr algn="l">
+              <a:spcAft>
+                <a:spcPts val="200"/>
+              </a:spcAft>
+            </a:pPr>
+            <a:r>
+              <a:rPr sz="1100" b="0">
+                <a:solidFill>
+                  <a:srgbClr val="1A1A1A"/>
+                </a:solidFill>
+                <a:latin typeface="맑은 고딕"/>
+              </a:rPr>
+              <a:t>• 식품: 이물 혼입·포장 불량 인라인 검출</a:t>
+            </a:r>
+          </a:p>
+        </p:txBody>
+      </p:sp>
+    </p:spTree>
+  </p:cSld>
+  <p:clrMapOvr>
+    <a:masterClrMapping/>
+  </p:clrMapOvr>
+</p:sld>
+</file>
+
+<file path=ppt/slides/slide11.xml><?xml version="1.0" encoding="utf-8"?>
+<p:sld xmlns:a="http://schemas.openxmlformats.org/drawingml/2006/main" xmlns:p="http://schemas.openxmlformats.org/presentationml/2006/main" xmlns:r="http://schemas.openxmlformats.org/officeDocument/2006/relationships">
+  <p:cSld>
+    <p:spTree>
+      <p:nvGrpSpPr>
+        <p:cNvPr id="1" name=""/>
+        <p:cNvGrpSpPr/>
+        <p:nvPr/>
+      </p:nvGrpSpPr>
+      <p:grpSpPr/>
+      <p:sp>
+        <p:nvSpPr>
+          <p:cNvPr id="2" name="Rectangle 1"/>
+          <p:cNvSpPr/>
+          <p:nvPr/>
+        </p:nvSpPr>
+        <p:spPr>
+          <a:xfrm>
+            <a:off x="0" y="0"/>
+            <a:ext cx="12188952" cy="6858000"/>
+          </a:xfrm>
+          <a:prstGeom prst="rect">
+            <a:avLst/>
+          </a:prstGeom>
+          <a:solidFill>
+            <a:srgbClr val="FFFFFF"/>
+          </a:solidFill>
+          <a:ln>
+            <a:noFill/>
+          </a:ln>
+        </p:spPr>
+        <p:style>
+          <a:lnRef idx="1">
+            <a:schemeClr val="accent1"/>
+          </a:lnRef>
+          <a:fillRef idx="3">
+            <a:schemeClr val="accent1"/>
+          </a:fillRef>
+          <a:effectRef idx="2">
+            <a:schemeClr val="accent1"/>
+          </a:effectRef>
+          <a:fontRef idx="minor">
+            <a:schemeClr val="lt1"/>
+          </a:fontRef>
+        </p:style>
+        <p:txBody>
+          <a:bodyPr rtlCol="0" anchor="ctr"/>
+          <a:lstStyle/>
+          <a:p>
+            <a:pPr algn="ctr"/>
+          </a:p>
+        </p:txBody>
+      </p:sp>
+      <p:sp>
+        <p:nvSpPr>
+          <p:cNvPr id="3" name="Rectangle 2"/>
+          <p:cNvSpPr/>
+          <p:nvPr/>
+        </p:nvSpPr>
+        <p:spPr>
+          <a:xfrm>
+            <a:off x="0" y="0"/>
+            <a:ext cx="12188952" cy="914400"/>
+          </a:xfrm>
+          <a:prstGeom prst="rect">
+            <a:avLst/>
+          </a:prstGeom>
+          <a:solidFill>
+            <a:srgbClr val="1A2E4A"/>
+          </a:solidFill>
+          <a:ln>
+            <a:noFill/>
+          </a:ln>
+        </p:spPr>
+        <p:style>
+          <a:lnRef idx="1">
+            <a:schemeClr val="accent1"/>
+          </a:lnRef>
+          <a:fillRef idx="3">
+            <a:schemeClr val="accent1"/>
+          </a:fillRef>
+          <a:effectRef idx="2">
+            <a:schemeClr val="accent1"/>
+          </a:effectRef>
+          <a:fontRef idx="minor">
+            <a:schemeClr val="lt1"/>
+          </a:fontRef>
+        </p:style>
+        <p:txBody>
+          <a:bodyPr rtlCol="0" anchor="ctr"/>
+          <a:lstStyle/>
+          <a:p>
+            <a:pPr algn="ctr"/>
+          </a:p>
+        </p:txBody>
+      </p:sp>
+      <p:sp>
+        <p:nvSpPr>
+          <p:cNvPr id="4" name="Rectangle 3"/>
+          <p:cNvSpPr/>
+          <p:nvPr/>
+        </p:nvSpPr>
+        <p:spPr>
+          <a:xfrm>
+            <a:off x="0" y="0"/>
+            <a:ext cx="73152" cy="914400"/>
+          </a:xfrm>
+          <a:prstGeom prst="rect">
+            <a:avLst/>
+          </a:prstGeom>
+          <a:solidFill>
+            <a:srgbClr val="CE0A2C"/>
+          </a:solidFill>
+          <a:ln>
+            <a:noFill/>
+          </a:ln>
+        </p:spPr>
+        <p:style>
+          <a:lnRef idx="1">
+            <a:schemeClr val="accent1"/>
+          </a:lnRef>
+          <a:fillRef idx="3">
+            <a:schemeClr val="accent1"/>
+          </a:fillRef>
+          <a:effectRef idx="2">
+            <a:schemeClr val="accent1"/>
+          </a:effectRef>
+          <a:fontRef idx="minor">
+            <a:schemeClr val="lt1"/>
+          </a:fontRef>
+        </p:style>
+        <p:txBody>
+          <a:bodyPr rtlCol="0" anchor="ctr"/>
+          <a:lstStyle/>
+          <a:p>
+            <a:pPr algn="ctr"/>
+          </a:p>
+        </p:txBody>
+      </p:sp>
+      <p:sp>
+        <p:nvSpPr>
+          <p:cNvPr id="5" name="TextBox 4"/>
+          <p:cNvSpPr txBox="1"/>
+          <p:nvPr/>
+        </p:nvSpPr>
+        <p:spPr>
+          <a:xfrm>
+            <a:off x="228600" y="73152"/>
+            <a:ext cx="11155680" cy="566928"/>
+          </a:xfrm>
+          <a:prstGeom prst="rect">
+            <a:avLst/>
+          </a:prstGeom>
+          <a:noFill/>
+        </p:spPr>
+        <p:txBody>
+          <a:bodyPr wrap="square">
+            <a:spAutoFit/>
+          </a:bodyPr>
+          <a:lstStyle/>
+          <a:p>
+            <a:pPr algn="l"/>
+            <a:r>
+              <a:rPr sz="2200" b="1">
+                <a:solidFill>
+                  <a:srgbClr val="FFFFFF"/>
+                </a:solidFill>
+                <a:latin typeface="맑은 고딕"/>
+              </a:rPr>
+              <a:t>[세미나③] 자동화 3D 측정 솔루션으로 품질혁신 — FARO Creaform</a:t>
+            </a:r>
+          </a:p>
+        </p:txBody>
+      </p:sp>
+      <p:sp>
+        <p:nvSpPr>
+          <p:cNvPr id="6" name="TextBox 5"/>
+          <p:cNvSpPr txBox="1"/>
+          <p:nvPr/>
+        </p:nvSpPr>
+        <p:spPr>
+          <a:xfrm>
+            <a:off x="228600" y="621792"/>
+            <a:ext cx="11430000" cy="274320"/>
+          </a:xfrm>
+          <a:prstGeom prst="rect">
+            <a:avLst/>
+          </a:prstGeom>
+          <a:noFill/>
+        </p:spPr>
+        <p:txBody>
+          <a:bodyPr wrap="square">
+            <a:spAutoFit/>
+          </a:bodyPr>
+          <a:lstStyle/>
+          <a:p>
+            <a:pPr algn="l"/>
+            <a:r>
+              <a:rPr sz="1100" b="0">
+                <a:solidFill>
+                  <a:srgbClr val="FF4C5C"/>
+                </a:solidFill>
+                <a:latin typeface="맑은 고딕"/>
+              </a:rPr>
+              <a:t>2026 AI자율제조혁신 컨퍼런스  |  Day 2 (7/2)  13:30~14:00  |  발표: 김건아 지사장 (아미텍코리아·FARO CREAFORM BU)</a:t>
+            </a:r>
+          </a:p>
+        </p:txBody>
+      </p:sp>
+      <p:sp>
+        <p:nvSpPr>
+          <p:cNvPr id="7" name="Rectangle 6"/>
+          <p:cNvSpPr/>
+          <p:nvPr/>
+        </p:nvSpPr>
+        <p:spPr>
+          <a:xfrm>
+            <a:off x="0" y="6583680"/>
+            <a:ext cx="12188952" cy="274320"/>
+          </a:xfrm>
+          <a:prstGeom prst="rect">
+            <a:avLst/>
+          </a:prstGeom>
+          <a:solidFill>
+            <a:srgbClr val="1A2E4A"/>
+          </a:solidFill>
+          <a:ln>
+            <a:noFill/>
+          </a:ln>
+        </p:spPr>
+        <p:style>
+          <a:lnRef idx="1">
+            <a:schemeClr val="accent1"/>
+          </a:lnRef>
+          <a:fillRef idx="3">
+            <a:schemeClr val="accent1"/>
+          </a:fillRef>
+          <a:effectRef idx="2">
+            <a:schemeClr val="accent1"/>
+          </a:effectRef>
+          <a:fontRef idx="minor">
+            <a:schemeClr val="lt1"/>
+          </a:fontRef>
+        </p:style>
+        <p:txBody>
+          <a:bodyPr rtlCol="0" anchor="ctr"/>
+          <a:lstStyle/>
+          <a:p>
+            <a:pPr algn="ctr"/>
+          </a:p>
+        </p:txBody>
+      </p:sp>
+      <p:sp>
+        <p:nvSpPr>
+          <p:cNvPr id="8" name="TextBox 7"/>
+          <p:cNvSpPr txBox="1"/>
+          <p:nvPr/>
+        </p:nvSpPr>
+        <p:spPr>
+          <a:xfrm>
+            <a:off x="182880" y="6601968"/>
+            <a:ext cx="8229600" cy="228600"/>
+          </a:xfrm>
+          <a:prstGeom prst="rect">
+            <a:avLst/>
+          </a:prstGeom>
+          <a:noFill/>
+        </p:spPr>
+        <p:txBody>
+          <a:bodyPr wrap="square">
+            <a:spAutoFit/>
+          </a:bodyPr>
+          <a:lstStyle/>
+          <a:p>
+            <a:pPr algn="l"/>
+            <a:r>
+              <a:rPr sz="1000" b="0">
+                <a:solidFill>
+                  <a:srgbClr val="FFFFFF"/>
+                </a:solidFill>
+                <a:latin typeface="맑은 고딕"/>
+              </a:rPr>
+              <a:t>LG전자 생산기술원  |  2026 부산로봇엑스포 관람 보고서</a:t>
+            </a:r>
+          </a:p>
+        </p:txBody>
+      </p:sp>
+      <p:sp>
+        <p:nvSpPr>
+          <p:cNvPr id="9" name="TextBox 8"/>
+          <p:cNvSpPr txBox="1"/>
+          <p:nvPr/>
+        </p:nvSpPr>
+        <p:spPr>
+          <a:xfrm>
+            <a:off x="10972800" y="6601968"/>
+            <a:ext cx="1097280" cy="228600"/>
+          </a:xfrm>
+          <a:prstGeom prst="rect">
+            <a:avLst/>
+          </a:prstGeom>
+          <a:noFill/>
+        </p:spPr>
+        <p:txBody>
+          <a:bodyPr wrap="square">
+            <a:spAutoFit/>
+          </a:bodyPr>
+          <a:lstStyle/>
+          <a:p>
+            <a:pPr algn="r"/>
+            <a:r>
+              <a:rPr sz="1000" b="0">
+                <a:solidFill>
+                  <a:srgbClr val="FFFFFF"/>
+                </a:solidFill>
+                <a:latin typeface="맑은 고딕"/>
+              </a:rPr>
+              <a:t>2026. 7. 3.</a:t>
+            </a:r>
+          </a:p>
+        </p:txBody>
+      </p:sp>
+      <p:sp>
+        <p:nvSpPr>
+          <p:cNvPr id="10" name="Rectangle 9"/>
+          <p:cNvSpPr/>
+          <p:nvPr/>
+        </p:nvSpPr>
+        <p:spPr>
+          <a:xfrm>
+            <a:off x="228600" y="1005840"/>
+            <a:ext cx="6812280" cy="5440680"/>
+          </a:xfrm>
+          <a:prstGeom prst="rect">
+            <a:avLst/>
+          </a:prstGeom>
+          <a:solidFill>
+            <a:srgbClr val="F2F2F2"/>
+          </a:solidFill>
+          <a:ln>
+            <a:noFill/>
+          </a:ln>
+        </p:spPr>
+        <p:style>
+          <a:lnRef idx="1">
+            <a:schemeClr val="accent1"/>
+          </a:lnRef>
+          <a:fillRef idx="3">
+            <a:schemeClr val="accent1"/>
+          </a:fillRef>
+          <a:effectRef idx="2">
+            <a:schemeClr val="accent1"/>
+          </a:effectRef>
+          <a:fontRef idx="minor">
+            <a:schemeClr val="lt1"/>
+          </a:fontRef>
+        </p:style>
+        <p:txBody>
+          <a:bodyPr rtlCol="0" anchor="ctr"/>
+          <a:lstStyle/>
+          <a:p>
+            <a:pPr algn="ctr"/>
+          </a:p>
+        </p:txBody>
+      </p:sp>
+      <p:sp>
+        <p:nvSpPr>
+          <p:cNvPr id="11" name="Rectangle 10"/>
+          <p:cNvSpPr/>
+          <p:nvPr/>
+        </p:nvSpPr>
+        <p:spPr>
+          <a:xfrm>
+            <a:off x="228600" y="1005840"/>
+            <a:ext cx="6812280" cy="384048"/>
+          </a:xfrm>
+          <a:prstGeom prst="rect">
+            <a:avLst/>
+          </a:prstGeom>
+          <a:solidFill>
+            <a:srgbClr val="1A2E4A"/>
+          </a:solidFill>
+          <a:ln>
+            <a:noFill/>
+          </a:ln>
+        </p:spPr>
+        <p:style>
+          <a:lnRef idx="1">
+            <a:schemeClr val="accent1"/>
+          </a:lnRef>
+          <a:fillRef idx="3">
+            <a:schemeClr val="accent1"/>
+          </a:fillRef>
+          <a:effectRef idx="2">
+            <a:schemeClr val="accent1"/>
+          </a:effectRef>
+          <a:fontRef idx="minor">
+            <a:schemeClr val="lt1"/>
+          </a:fontRef>
+        </p:style>
+        <p:txBody>
+          <a:bodyPr rtlCol="0" anchor="ctr"/>
+          <a:lstStyle/>
+          <a:p>
+            <a:pPr algn="ctr"/>
+          </a:p>
+        </p:txBody>
+      </p:sp>
+      <p:sp>
+        <p:nvSpPr>
+          <p:cNvPr id="12" name="TextBox 11"/>
+          <p:cNvSpPr txBox="1"/>
+          <p:nvPr/>
+        </p:nvSpPr>
+        <p:spPr>
+          <a:xfrm>
+            <a:off x="228600" y="1005840"/>
+            <a:ext cx="6812280" cy="384048"/>
+          </a:xfrm>
+          <a:prstGeom prst="rect">
+            <a:avLst/>
+          </a:prstGeom>
+          <a:noFill/>
+        </p:spPr>
+        <p:txBody>
+          <a:bodyPr wrap="square">
+            <a:spAutoFit/>
+          </a:bodyPr>
+          <a:lstStyle/>
+          <a:p>
+            <a:pPr algn="ctr"/>
+            <a:r>
+              <a:rPr sz="1200" b="1">
+                <a:solidFill>
+                  <a:srgbClr val="FFFFFF"/>
+                </a:solidFill>
+                <a:latin typeface="맑은 고딕"/>
+              </a:rPr>
+              <a:t>파로 크레아폼 (FARO Creaform / 아미텍코리아)  —  발표 내용 요약</a:t>
+            </a:r>
+          </a:p>
+        </p:txBody>
+      </p:sp>
+      <p:sp>
+        <p:nvSpPr>
+          <p:cNvPr id="13" name="TextBox 12"/>
+          <p:cNvSpPr txBox="1"/>
+          <p:nvPr/>
+        </p:nvSpPr>
+        <p:spPr>
+          <a:xfrm>
+            <a:off x="347472" y="1444752"/>
+            <a:ext cx="6583680" cy="274320"/>
+          </a:xfrm>
+          <a:prstGeom prst="rect">
+            <a:avLst/>
+          </a:prstGeom>
+          <a:noFill/>
+        </p:spPr>
+        <p:txBody>
+          <a:bodyPr wrap="square">
+            <a:spAutoFit/>
+          </a:bodyPr>
+          <a:lstStyle/>
+          <a:p>
+            <a:pPr algn="l"/>
+            <a:r>
+              <a:rPr sz="1200" b="1">
+                <a:solidFill>
+                  <a:srgbClr val="1A2E4A"/>
+                </a:solidFill>
+                <a:latin typeface="맑은 고딕"/>
+              </a:rPr>
+              <a:t>■ 발표 주제</a:t>
+            </a:r>
+          </a:p>
+        </p:txBody>
+      </p:sp>
+      <p:sp>
+        <p:nvSpPr>
+          <p:cNvPr id="14" name="TextBox 13"/>
+          <p:cNvSpPr txBox="1"/>
+          <p:nvPr/>
+        </p:nvSpPr>
+        <p:spPr>
+          <a:xfrm>
+            <a:off x="347472" y="1719072"/>
+            <a:ext cx="6583680" cy="274320"/>
+          </a:xfrm>
+          <a:prstGeom prst="rect">
+            <a:avLst/>
+          </a:prstGeom>
+          <a:noFill/>
+        </p:spPr>
+        <p:txBody>
+          <a:bodyPr wrap="square">
+            <a:spAutoFit/>
+          </a:bodyPr>
+          <a:lstStyle/>
+          <a:p>
+            <a:pPr algn="l"/>
+            <a:r>
+              <a:rPr sz="1200" b="0">
+                <a:solidFill>
+                  <a:srgbClr val="1A1A1A"/>
+                </a:solidFill>
+                <a:latin typeface="맑은 고딕"/>
+              </a:rPr>
+              <a:t>자동화 3D 측정 솔루션으로 제조 품질혁신 (인라인 전수검사 실현)</a:t>
+            </a:r>
+          </a:p>
+        </p:txBody>
+      </p:sp>
+      <p:sp>
+        <p:nvSpPr>
+          <p:cNvPr id="15" name="TextBox 14"/>
+          <p:cNvSpPr txBox="1"/>
+          <p:nvPr/>
+        </p:nvSpPr>
+        <p:spPr>
+          <a:xfrm>
+            <a:off x="347472" y="2066543"/>
+            <a:ext cx="6583680" cy="274320"/>
+          </a:xfrm>
+          <a:prstGeom prst="rect">
+            <a:avLst/>
+          </a:prstGeom>
+          <a:noFill/>
+        </p:spPr>
+        <p:txBody>
+          <a:bodyPr wrap="square">
+            <a:spAutoFit/>
+          </a:bodyPr>
+          <a:lstStyle/>
+          <a:p>
+            <a:pPr algn="l"/>
+            <a:r>
+              <a:rPr sz="1200" b="1">
+                <a:solidFill>
+                  <a:srgbClr val="1A2E4A"/>
+                </a:solidFill>
+                <a:latin typeface="맑은 고딕"/>
+              </a:rPr>
+              <a:t>■ 핵심 발표 내용</a:t>
+            </a:r>
+          </a:p>
+        </p:txBody>
+      </p:sp>
+      <p:sp>
+        <p:nvSpPr>
+          <p:cNvPr id="16" name="TextBox 15"/>
+          <p:cNvSpPr txBox="1"/>
+          <p:nvPr/>
+        </p:nvSpPr>
+        <p:spPr>
+          <a:xfrm>
+            <a:off x="347472" y="2377440"/>
+            <a:ext cx="6583680" cy="1828800"/>
+          </a:xfrm>
+          <a:prstGeom prst="rect">
+            <a:avLst/>
+          </a:prstGeom>
+          <a:noFill/>
+        </p:spPr>
+        <p:txBody>
+          <a:bodyPr wrap="square">
+            <a:spAutoFit/>
+          </a:bodyPr>
+          <a:lstStyle/>
+          <a:p>
+            <a:pPr algn="l">
+              <a:spcAft>
+                <a:spcPts val="200"/>
+              </a:spcAft>
+            </a:pPr>
+            <a:r>
+              <a:rPr sz="1150" b="0">
+                <a:solidFill>
+                  <a:srgbClr val="1A1A1A"/>
+                </a:solidFill>
+                <a:latin typeface="맑은 고딕"/>
+              </a:rPr>
+              <a:t>• 포터블 3D 스캐너 기반 비접촉 치수 측정 — 기존 CMM(좌표측정기) 대비 측정 시간 최대 80% 단축</a:t>
+            </a:r>
+          </a:p>
+          <a:p>
+            <a:pPr algn="l">
+              <a:spcAft>
+                <a:spcPts val="200"/>
+              </a:spcAft>
+            </a:pPr>
+            <a:r>
+              <a:rPr sz="1150" b="0">
+                <a:solidFill>
+                  <a:srgbClr val="1A1A1A"/>
+                </a:solidFill>
+                <a:latin typeface="맑은 고딕"/>
+              </a:rPr>
+              <a:t>• 인라인 자동화: 생산 라인 내 로봇 탑재형 스캐너로 샘플링(10~20%) → 전수검사(100%) 전환</a:t>
+            </a:r>
+          </a:p>
+          <a:p>
+            <a:pPr algn="l">
+              <a:spcAft>
+                <a:spcPts val="200"/>
+              </a:spcAft>
+            </a:pPr>
+            <a:r>
+              <a:rPr sz="1150" b="0">
+                <a:solidFill>
+                  <a:srgbClr val="1A1A1A"/>
+                </a:solidFill>
+                <a:latin typeface="맑은 고딕"/>
+              </a:rPr>
+              <a:t>• 자동차 사례: 프레스 패널 변형 검사, 차체 용접부 3D 치수 측정 — 공정 중 즉시 이상 감지</a:t>
+            </a:r>
+          </a:p>
+          <a:p>
+            <a:pPr algn="l">
+              <a:spcAft>
+                <a:spcPts val="200"/>
+              </a:spcAft>
+            </a:pPr>
+            <a:r>
+              <a:rPr sz="1150" b="0">
+                <a:solidFill>
+                  <a:srgbClr val="1A1A1A"/>
+                </a:solidFill>
+                <a:latin typeface="맑은 고딕"/>
+              </a:rPr>
+              <a:t>• 항공우주 사례: 복잡 곡면 부품 비접촉 전수검사, 인간 오류 제거 — 납품 불량 제로 달성</a:t>
+            </a:r>
+          </a:p>
+          <a:p>
+            <a:pPr algn="l">
+              <a:spcAft>
+                <a:spcPts val="200"/>
+              </a:spcAft>
+            </a:pPr>
+            <a:r>
+              <a:rPr sz="1150" b="0">
+                <a:solidFill>
+                  <a:srgbClr val="1A1A1A"/>
+                </a:solidFill>
+                <a:latin typeface="맑은 고딕"/>
+              </a:rPr>
+              <a:t>• 디지털 트윈 연계: 3D 스캔 데이터 → 공정 파라미터 AI 자동 보정 → 품질 예측 제어</a:t>
+            </a:r>
+          </a:p>
+          <a:p>
+            <a:pPr algn="l">
+              <a:spcAft>
+                <a:spcPts val="200"/>
+              </a:spcAft>
+            </a:pPr>
+            <a:r>
+              <a:rPr sz="1150" b="0">
+                <a:solidFill>
+                  <a:srgbClr val="1A1A1A"/>
+                </a:solidFill>
+                <a:latin typeface="맑은 고딕"/>
+              </a:rPr>
+              <a:t>• ScanGauge SW: 측정 → 3D 편차 시각화 → 자동 리포트 생성 원스톱 처리</a:t>
+            </a:r>
+          </a:p>
+        </p:txBody>
+      </p:sp>
+      <p:sp>
+        <p:nvSpPr>
+          <p:cNvPr id="17" name="Rectangle 16"/>
+          <p:cNvSpPr/>
+          <p:nvPr/>
+        </p:nvSpPr>
+        <p:spPr>
+          <a:xfrm>
+            <a:off x="347472" y="4251960"/>
+            <a:ext cx="6583680" cy="27432"/>
+          </a:xfrm>
+          <a:prstGeom prst="rect">
+            <a:avLst/>
+          </a:prstGeom>
+          <a:solidFill>
+            <a:srgbClr val="CE0A2C"/>
+          </a:solidFill>
+          <a:ln>
+            <a:noFill/>
+          </a:ln>
+        </p:spPr>
+        <p:style>
+          <a:lnRef idx="1">
+            <a:schemeClr val="accent1"/>
+          </a:lnRef>
+          <a:fillRef idx="3">
+            <a:schemeClr val="accent1"/>
+          </a:fillRef>
+          <a:effectRef idx="2">
+            <a:schemeClr val="accent1"/>
+          </a:effectRef>
+          <a:fontRef idx="minor">
+            <a:schemeClr val="lt1"/>
+          </a:fontRef>
+        </p:style>
+        <p:txBody>
+          <a:bodyPr rtlCol="0" anchor="ctr"/>
+          <a:lstStyle/>
+          <a:p>
+            <a:pPr algn="ctr"/>
+          </a:p>
+        </p:txBody>
+      </p:sp>
+      <p:sp>
+        <p:nvSpPr>
+          <p:cNvPr id="18" name="TextBox 17"/>
+          <p:cNvSpPr txBox="1"/>
+          <p:nvPr/>
+        </p:nvSpPr>
+        <p:spPr>
+          <a:xfrm>
+            <a:off x="347472" y="4315968"/>
+            <a:ext cx="6583680" cy="274320"/>
+          </a:xfrm>
+          <a:prstGeom prst="rect">
+            <a:avLst/>
+          </a:prstGeom>
+          <a:noFill/>
+        </p:spPr>
+        <p:txBody>
+          <a:bodyPr wrap="square">
+            <a:spAutoFit/>
+          </a:bodyPr>
+          <a:lstStyle/>
+          <a:p>
+            <a:pPr algn="l"/>
+            <a:r>
+              <a:rPr sz="1200" b="1">
+                <a:solidFill>
+                  <a:srgbClr val="CE0A2C"/>
+                </a:solidFill>
+                <a:latin typeface="맑은 고딕"/>
+              </a:rPr>
+              <a:t>■ LG생산기술원 시사점</a:t>
+            </a:r>
+          </a:p>
+        </p:txBody>
+      </p:sp>
+      <p:sp>
+        <p:nvSpPr>
+          <p:cNvPr id="19" name="TextBox 18"/>
+          <p:cNvSpPr txBox="1"/>
+          <p:nvPr/>
+        </p:nvSpPr>
+        <p:spPr>
+          <a:xfrm>
+            <a:off x="347472" y="4645152"/>
+            <a:ext cx="6583680" cy="868680"/>
+          </a:xfrm>
+          <a:prstGeom prst="rect">
+            <a:avLst/>
+          </a:prstGeom>
+          <a:noFill/>
+        </p:spPr>
+        <p:txBody>
+          <a:bodyPr wrap="square">
+            <a:spAutoFit/>
+          </a:bodyPr>
+          <a:lstStyle/>
+          <a:p>
+            <a:pPr algn="l">
+              <a:spcAft>
+                <a:spcPts val="200"/>
+              </a:spcAft>
+            </a:pPr>
+            <a:r>
+              <a:rPr sz="1100" b="0">
+                <a:solidFill>
+                  <a:srgbClr val="1A1A1A"/>
+                </a:solidFill>
+                <a:latin typeface="맑은 고딕"/>
+              </a:rPr>
+              <a:t>▶ 냉장고·세탁기 메탈 케이스 치수 전수검사에 인라인 3D 스캐너 도입 — 불량 유출 원천 차단</a:t>
+            </a:r>
+          </a:p>
+          <a:p>
+            <a:pPr algn="l">
+              <a:spcAft>
+                <a:spcPts val="200"/>
+              </a:spcAft>
+            </a:pPr>
+            <a:r>
+              <a:rPr sz="1100" b="0">
+                <a:solidFill>
+                  <a:srgbClr val="1A1A1A"/>
+                </a:solidFill>
+                <a:latin typeface="맑은 고딕"/>
+              </a:rPr>
+              <a:t>▶ 7축 용접 로봇에 3D 스캐너 탑재 → 용접 직후 비드 품질 자동 3D 측정 (성우하이텍 레퍼런스)</a:t>
+            </a:r>
+          </a:p>
+          <a:p>
+            <a:pPr algn="l">
+              <a:spcAft>
+                <a:spcPts val="200"/>
+              </a:spcAft>
+            </a:pPr>
+            <a:r>
+              <a:rPr sz="1100" b="0">
+                <a:solidFill>
+                  <a:srgbClr val="1A1A1A"/>
+                </a:solidFill>
+                <a:latin typeface="맑은 고딕"/>
+              </a:rPr>
+              <a:t>▶ 아미텍코리아와 PoC 협의 권고 — 파일럿 라인(창원) 선정 후 3개월 실증 후 전개</a:t>
+            </a:r>
+          </a:p>
+        </p:txBody>
+      </p:sp>
+      <p:pic>
+        <p:nvPicPr>
+          <p:cNvPr id="20" name="Picture 19" descr="image.png"/>
+          <p:cNvPicPr>
+            <a:picLocks noChangeAspect="1"/>
+          </p:cNvPicPr>
+          <p:nvPr/>
+        </p:nvPicPr>
+        <p:blipFill>
+          <a:blip r:embed="rId2"/>
+          <a:stretch>
+            <a:fillRect/>
+          </a:stretch>
+        </p:blipFill>
+        <p:spPr>
+          <a:xfrm>
+            <a:off x="7223760" y="1005840"/>
+            <a:ext cx="4736592" cy="2926080"/>
+          </a:xfrm>
+          <a:prstGeom prst="rect">
+            <a:avLst/>
+          </a:prstGeom>
+        </p:spPr>
+      </p:pic>
+      <p:sp>
+        <p:nvSpPr>
+          <p:cNvPr id="21" name="TextBox 20"/>
+          <p:cNvSpPr txBox="1"/>
+          <p:nvPr/>
+        </p:nvSpPr>
+        <p:spPr>
+          <a:xfrm>
+            <a:off x="7223760" y="3977639"/>
+            <a:ext cx="4736592" cy="274320"/>
+          </a:xfrm>
+          <a:prstGeom prst="rect">
+            <a:avLst/>
+          </a:prstGeom>
+          <a:noFill/>
+        </p:spPr>
+        <p:txBody>
+          <a:bodyPr wrap="square">
+            <a:spAutoFit/>
+          </a:bodyPr>
+          <a:lstStyle/>
+          <a:p>
+            <a:pPr algn="ctr"/>
+            <a:r>
+              <a:rPr sz="950" b="0">
+                <a:solidFill>
+                  <a:srgbClr val="555555"/>
+                </a:solidFill>
+                <a:latin typeface="맑은 고딕"/>
+              </a:rPr>
+              <a:t>▲ FARO Creaform 3D 측정 자동화 프로세스 개념도</a:t>
+            </a:r>
+          </a:p>
+        </p:txBody>
+      </p:sp>
+      <p:sp>
+        <p:nvSpPr>
+          <p:cNvPr id="22" name="Rectangle 21"/>
+          <p:cNvSpPr/>
+          <p:nvPr/>
+        </p:nvSpPr>
+        <p:spPr>
+          <a:xfrm>
+            <a:off x="7223760" y="4251960"/>
+            <a:ext cx="4736592" cy="2121408"/>
+          </a:xfrm>
+          <a:prstGeom prst="rect">
+            <a:avLst/>
+          </a:prstGeom>
+          <a:solidFill>
+            <a:srgbClr val="F2F2F2"/>
+          </a:solidFill>
+          <a:ln>
+            <a:noFill/>
+          </a:ln>
+        </p:spPr>
+        <p:style>
+          <a:lnRef idx="1">
+            <a:schemeClr val="accent1"/>
+          </a:lnRef>
+          <a:fillRef idx="3">
+            <a:schemeClr val="accent1"/>
+          </a:fillRef>
+          <a:effectRef idx="2">
+            <a:schemeClr val="accent1"/>
+          </a:effectRef>
+          <a:fontRef idx="minor">
+            <a:schemeClr val="lt1"/>
+          </a:fontRef>
+        </p:style>
+        <p:txBody>
+          <a:bodyPr rtlCol="0" anchor="ctr"/>
+          <a:lstStyle/>
+          <a:p>
+            <a:pPr algn="ctr"/>
+          </a:p>
+        </p:txBody>
+      </p:sp>
+      <p:sp>
+        <p:nvSpPr>
+          <p:cNvPr id="23" name="Rectangle 22"/>
+          <p:cNvSpPr/>
+          <p:nvPr/>
+        </p:nvSpPr>
+        <p:spPr>
+          <a:xfrm>
+            <a:off x="7223760" y="4251960"/>
+            <a:ext cx="45720" cy="2121408"/>
+          </a:xfrm>
+          <a:prstGeom prst="rect">
+            <a:avLst/>
+          </a:prstGeom>
+          <a:solidFill>
+            <a:srgbClr val="1A7A3C"/>
+          </a:solidFill>
+          <a:ln>
+            <a:noFill/>
+          </a:ln>
+        </p:spPr>
+        <p:style>
+          <a:lnRef idx="1">
+            <a:schemeClr val="accent1"/>
+          </a:lnRef>
+          <a:fillRef idx="3">
+            <a:schemeClr val="accent1"/>
+          </a:fillRef>
+          <a:effectRef idx="2">
+            <a:schemeClr val="accent1"/>
+          </a:effectRef>
+          <a:fontRef idx="minor">
+            <a:schemeClr val="lt1"/>
+          </a:fontRef>
+        </p:style>
+        <p:txBody>
+          <a:bodyPr rtlCol="0" anchor="ctr"/>
+          <a:lstStyle/>
+          <a:p>
+            <a:pPr algn="ctr"/>
+          </a:p>
+        </p:txBody>
+      </p:sp>
+      <p:sp>
+        <p:nvSpPr>
+          <p:cNvPr id="24" name="TextBox 23"/>
+          <p:cNvSpPr txBox="1"/>
+          <p:nvPr/>
+        </p:nvSpPr>
+        <p:spPr>
+          <a:xfrm>
+            <a:off x="7315200" y="4297680"/>
+            <a:ext cx="4572000" cy="2011680"/>
+          </a:xfrm>
+          <a:prstGeom prst="rect">
+            <a:avLst/>
+          </a:prstGeom>
+          <a:noFill/>
+        </p:spPr>
+        <p:txBody>
+          <a:bodyPr wrap="square">
+            <a:spAutoFit/>
+          </a:bodyPr>
+          <a:lstStyle/>
+          <a:p>
+            <a:pPr algn="l">
+              <a:spcAft>
+                <a:spcPts val="200"/>
+              </a:spcAft>
+            </a:pPr>
+            <a:r>
+              <a:rPr sz="1100" b="0">
+                <a:solidFill>
+                  <a:srgbClr val="1A1A1A"/>
+                </a:solidFill>
+                <a:latin typeface="맑은 고딕"/>
+              </a:rPr>
+              <a:t>산업별 적용 효과</a:t>
+            </a:r>
+          </a:p>
+          <a:p>
+            <a:pPr algn="l">
+              <a:spcAft>
+                <a:spcPts val="200"/>
+              </a:spcAft>
+            </a:pPr>
+            <a:r>
+              <a:rPr sz="1100" b="0">
+                <a:solidFill>
+                  <a:srgbClr val="1A1A1A"/>
+                </a:solidFill>
+                <a:latin typeface="맑은 고딕"/>
+              </a:rPr>
+              <a:t>• 자동차: 프레스 패널 치수 인라인 전수검사 → 후공정 불량 제거</a:t>
+            </a:r>
+          </a:p>
+          <a:p>
+            <a:pPr algn="l">
+              <a:spcAft>
+                <a:spcPts val="200"/>
+              </a:spcAft>
+            </a:pPr>
+            <a:r>
+              <a:rPr sz="1100" b="0">
+                <a:solidFill>
+                  <a:srgbClr val="1A1A1A"/>
+                </a:solidFill>
+                <a:latin typeface="맑은 고딕"/>
+              </a:rPr>
+              <a:t>• 항공우주: 복잡 곡면 부품 비접촉 검사 납품 불량 제로</a:t>
+            </a:r>
+          </a:p>
+          <a:p>
+            <a:pPr algn="l">
+              <a:spcAft>
+                <a:spcPts val="200"/>
+              </a:spcAft>
+            </a:pPr>
+            <a:r>
+              <a:rPr sz="1100" b="0">
+                <a:solidFill>
+                  <a:srgbClr val="1A1A1A"/>
+                </a:solidFill>
+                <a:latin typeface="맑은 고딕"/>
+              </a:rPr>
+              <a:t>• 중공업: 대형 용접 구조물 변형량 정밀 측정</a:t>
+            </a:r>
+          </a:p>
+          <a:p>
+            <a:pPr algn="l">
+              <a:spcAft>
+                <a:spcPts val="200"/>
+              </a:spcAft>
+            </a:pPr>
+            <a:r>
+              <a:rPr sz="1100" b="0">
+                <a:solidFill>
+                  <a:srgbClr val="1A1A1A"/>
+                </a:solidFill>
+                <a:latin typeface="맑은 고딕"/>
+              </a:rPr>
+              <a:t>• 전자: 반도체 지그·금형 정밀 치수 검증</a:t>
+            </a:r>
+          </a:p>
+        </p:txBody>
+      </p:sp>
+    </p:spTree>
+  </p:cSld>
+  <p:clrMapOvr>
+    <a:masterClrMapping/>
+  </p:clrMapOvr>
+</p:sld>
+</file>
+
 <file path=ppt/slides/slide2.xml><?xml version="1.0" encoding="utf-8"?>
 <p:sld xmlns:a="http://schemas.openxmlformats.org/drawingml/2006/main" xmlns:p="http://schemas.openxmlformats.org/presentationml/2006/main" xmlns:r="http://schemas.openxmlformats.org/officeDocument/2006/relationships">
   <p:cSld>
@@ -16032,6 +18179,1062 @@
                 <a:latin typeface="맑은 고딕"/>
               </a:rPr>
               <a:t>  ▸ 위 5개 단기 실행 과제를 6개월 이내 착수하여 LG전자 생산기술원의 제조 자동화 역량을 가속화할 것을 제언합니다.</a:t>
+            </a:r>
+          </a:p>
+        </p:txBody>
+      </p:sp>
+    </p:spTree>
+  </p:cSld>
+  <p:clrMapOvr>
+    <a:masterClrMapping/>
+  </p:clrMapOvr>
+</p:sld>
+</file>
+
+<file path=ppt/slides/slide9.xml><?xml version="1.0" encoding="utf-8"?>
+<p:sld xmlns:a="http://schemas.openxmlformats.org/drawingml/2006/main" xmlns:p="http://schemas.openxmlformats.org/presentationml/2006/main" xmlns:r="http://schemas.openxmlformats.org/officeDocument/2006/relationships">
+  <p:cSld>
+    <p:spTree>
+      <p:nvGrpSpPr>
+        <p:cNvPr id="1" name=""/>
+        <p:cNvGrpSpPr/>
+        <p:nvPr/>
+      </p:nvGrpSpPr>
+      <p:grpSpPr/>
+      <p:sp>
+        <p:nvSpPr>
+          <p:cNvPr id="2" name="Rectangle 1"/>
+          <p:cNvSpPr/>
+          <p:nvPr/>
+        </p:nvSpPr>
+        <p:spPr>
+          <a:xfrm>
+            <a:off x="0" y="0"/>
+            <a:ext cx="12188952" cy="6858000"/>
+          </a:xfrm>
+          <a:prstGeom prst="rect">
+            <a:avLst/>
+          </a:prstGeom>
+          <a:solidFill>
+            <a:srgbClr val="FFFFFF"/>
+          </a:solidFill>
+          <a:ln>
+            <a:noFill/>
+          </a:ln>
+        </p:spPr>
+        <p:style>
+          <a:lnRef idx="1">
+            <a:schemeClr val="accent1"/>
+          </a:lnRef>
+          <a:fillRef idx="3">
+            <a:schemeClr val="accent1"/>
+          </a:fillRef>
+          <a:effectRef idx="2">
+            <a:schemeClr val="accent1"/>
+          </a:effectRef>
+          <a:fontRef idx="minor">
+            <a:schemeClr val="lt1"/>
+          </a:fontRef>
+        </p:style>
+        <p:txBody>
+          <a:bodyPr rtlCol="0" anchor="ctr"/>
+          <a:lstStyle/>
+          <a:p>
+            <a:pPr algn="ctr"/>
+          </a:p>
+        </p:txBody>
+      </p:sp>
+      <p:sp>
+        <p:nvSpPr>
+          <p:cNvPr id="3" name="Rectangle 2"/>
+          <p:cNvSpPr/>
+          <p:nvPr/>
+        </p:nvSpPr>
+        <p:spPr>
+          <a:xfrm>
+            <a:off x="0" y="0"/>
+            <a:ext cx="12188952" cy="914400"/>
+          </a:xfrm>
+          <a:prstGeom prst="rect">
+            <a:avLst/>
+          </a:prstGeom>
+          <a:solidFill>
+            <a:srgbClr val="1A2E4A"/>
+          </a:solidFill>
+          <a:ln>
+            <a:noFill/>
+          </a:ln>
+        </p:spPr>
+        <p:style>
+          <a:lnRef idx="1">
+            <a:schemeClr val="accent1"/>
+          </a:lnRef>
+          <a:fillRef idx="3">
+            <a:schemeClr val="accent1"/>
+          </a:fillRef>
+          <a:effectRef idx="2">
+            <a:schemeClr val="accent1"/>
+          </a:effectRef>
+          <a:fontRef idx="minor">
+            <a:schemeClr val="lt1"/>
+          </a:fontRef>
+        </p:style>
+        <p:txBody>
+          <a:bodyPr rtlCol="0" anchor="ctr"/>
+          <a:lstStyle/>
+          <a:p>
+            <a:pPr algn="ctr"/>
+          </a:p>
+        </p:txBody>
+      </p:sp>
+      <p:sp>
+        <p:nvSpPr>
+          <p:cNvPr id="4" name="Rectangle 3"/>
+          <p:cNvSpPr/>
+          <p:nvPr/>
+        </p:nvSpPr>
+        <p:spPr>
+          <a:xfrm>
+            <a:off x="0" y="0"/>
+            <a:ext cx="73152" cy="914400"/>
+          </a:xfrm>
+          <a:prstGeom prst="rect">
+            <a:avLst/>
+          </a:prstGeom>
+          <a:solidFill>
+            <a:srgbClr val="CE0A2C"/>
+          </a:solidFill>
+          <a:ln>
+            <a:noFill/>
+          </a:ln>
+        </p:spPr>
+        <p:style>
+          <a:lnRef idx="1">
+            <a:schemeClr val="accent1"/>
+          </a:lnRef>
+          <a:fillRef idx="3">
+            <a:schemeClr val="accent1"/>
+          </a:fillRef>
+          <a:effectRef idx="2">
+            <a:schemeClr val="accent1"/>
+          </a:effectRef>
+          <a:fontRef idx="minor">
+            <a:schemeClr val="lt1"/>
+          </a:fontRef>
+        </p:style>
+        <p:txBody>
+          <a:bodyPr rtlCol="0" anchor="ctr"/>
+          <a:lstStyle/>
+          <a:p>
+            <a:pPr algn="ctr"/>
+          </a:p>
+        </p:txBody>
+      </p:sp>
+      <p:sp>
+        <p:nvSpPr>
+          <p:cNvPr id="5" name="TextBox 4"/>
+          <p:cNvSpPr txBox="1"/>
+          <p:nvPr/>
+        </p:nvSpPr>
+        <p:spPr>
+          <a:xfrm>
+            <a:off x="228600" y="73152"/>
+            <a:ext cx="11155680" cy="566928"/>
+          </a:xfrm>
+          <a:prstGeom prst="rect">
+            <a:avLst/>
+          </a:prstGeom>
+          <a:noFill/>
+        </p:spPr>
+        <p:txBody>
+          <a:bodyPr wrap="square">
+            <a:spAutoFit/>
+          </a:bodyPr>
+          <a:lstStyle/>
+          <a:p>
+            <a:pPr algn="l"/>
+            <a:r>
+              <a:rPr sz="2200" b="1">
+                <a:solidFill>
+                  <a:srgbClr val="FFFFFF"/>
+                </a:solidFill>
+                <a:latin typeface="맑은 고딕"/>
+              </a:rPr>
+              <a:t>[세미나①] AI 기반 3D Vision 자율제조 — 픽킷코리아 (Pickit)</a:t>
+            </a:r>
+          </a:p>
+        </p:txBody>
+      </p:sp>
+      <p:sp>
+        <p:nvSpPr>
+          <p:cNvPr id="6" name="TextBox 5"/>
+          <p:cNvSpPr txBox="1"/>
+          <p:nvPr/>
+        </p:nvSpPr>
+        <p:spPr>
+          <a:xfrm>
+            <a:off x="228600" y="621792"/>
+            <a:ext cx="11430000" cy="274320"/>
+          </a:xfrm>
+          <a:prstGeom prst="rect">
+            <a:avLst/>
+          </a:prstGeom>
+          <a:noFill/>
+        </p:spPr>
+        <p:txBody>
+          <a:bodyPr wrap="square">
+            <a:spAutoFit/>
+          </a:bodyPr>
+          <a:lstStyle/>
+          <a:p>
+            <a:pPr algn="l"/>
+            <a:r>
+              <a:rPr sz="1100" b="0">
+                <a:solidFill>
+                  <a:srgbClr val="FF4C5C"/>
+                </a:solidFill>
+                <a:latin typeface="맑은 고딕"/>
+              </a:rPr>
+              <a:t>2026 AI자율제조혁신 컨퍼런스  |  Day 1 (7/1)  13:30~14:00  |  벡스코 제2전시장 4홀 컨퍼런스룸  |  주관: ㈜첨단·벡스코·한국산업전람</a:t>
+            </a:r>
+          </a:p>
+        </p:txBody>
+      </p:sp>
+      <p:sp>
+        <p:nvSpPr>
+          <p:cNvPr id="7" name="Rectangle 6"/>
+          <p:cNvSpPr/>
+          <p:nvPr/>
+        </p:nvSpPr>
+        <p:spPr>
+          <a:xfrm>
+            <a:off x="0" y="6583680"/>
+            <a:ext cx="12188952" cy="274320"/>
+          </a:xfrm>
+          <a:prstGeom prst="rect">
+            <a:avLst/>
+          </a:prstGeom>
+          <a:solidFill>
+            <a:srgbClr val="1A2E4A"/>
+          </a:solidFill>
+          <a:ln>
+            <a:noFill/>
+          </a:ln>
+        </p:spPr>
+        <p:style>
+          <a:lnRef idx="1">
+            <a:schemeClr val="accent1"/>
+          </a:lnRef>
+          <a:fillRef idx="3">
+            <a:schemeClr val="accent1"/>
+          </a:fillRef>
+          <a:effectRef idx="2">
+            <a:schemeClr val="accent1"/>
+          </a:effectRef>
+          <a:fontRef idx="minor">
+            <a:schemeClr val="lt1"/>
+          </a:fontRef>
+        </p:style>
+        <p:txBody>
+          <a:bodyPr rtlCol="0" anchor="ctr"/>
+          <a:lstStyle/>
+          <a:p>
+            <a:pPr algn="ctr"/>
+          </a:p>
+        </p:txBody>
+      </p:sp>
+      <p:sp>
+        <p:nvSpPr>
+          <p:cNvPr id="8" name="TextBox 7"/>
+          <p:cNvSpPr txBox="1"/>
+          <p:nvPr/>
+        </p:nvSpPr>
+        <p:spPr>
+          <a:xfrm>
+            <a:off x="182880" y="6601968"/>
+            <a:ext cx="8229600" cy="228600"/>
+          </a:xfrm>
+          <a:prstGeom prst="rect">
+            <a:avLst/>
+          </a:prstGeom>
+          <a:noFill/>
+        </p:spPr>
+        <p:txBody>
+          <a:bodyPr wrap="square">
+            <a:spAutoFit/>
+          </a:bodyPr>
+          <a:lstStyle/>
+          <a:p>
+            <a:pPr algn="l"/>
+            <a:r>
+              <a:rPr sz="1000" b="0">
+                <a:solidFill>
+                  <a:srgbClr val="FFFFFF"/>
+                </a:solidFill>
+                <a:latin typeface="맑은 고딕"/>
+              </a:rPr>
+              <a:t>LG전자 생산기술원  |  2026 부산로봇엑스포 관람 보고서</a:t>
+            </a:r>
+          </a:p>
+        </p:txBody>
+      </p:sp>
+      <p:sp>
+        <p:nvSpPr>
+          <p:cNvPr id="9" name="TextBox 8"/>
+          <p:cNvSpPr txBox="1"/>
+          <p:nvPr/>
+        </p:nvSpPr>
+        <p:spPr>
+          <a:xfrm>
+            <a:off x="10972800" y="6601968"/>
+            <a:ext cx="1097280" cy="228600"/>
+          </a:xfrm>
+          <a:prstGeom prst="rect">
+            <a:avLst/>
+          </a:prstGeom>
+          <a:noFill/>
+        </p:spPr>
+        <p:txBody>
+          <a:bodyPr wrap="square">
+            <a:spAutoFit/>
+          </a:bodyPr>
+          <a:lstStyle/>
+          <a:p>
+            <a:pPr algn="r"/>
+            <a:r>
+              <a:rPr sz="1000" b="0">
+                <a:solidFill>
+                  <a:srgbClr val="FFFFFF"/>
+                </a:solidFill>
+                <a:latin typeface="맑은 고딕"/>
+              </a:rPr>
+              <a:t>2026. 7. 3.</a:t>
+            </a:r>
+          </a:p>
+        </p:txBody>
+      </p:sp>
+      <p:sp>
+        <p:nvSpPr>
+          <p:cNvPr id="10" name="Rectangle 9"/>
+          <p:cNvSpPr/>
+          <p:nvPr/>
+        </p:nvSpPr>
+        <p:spPr>
+          <a:xfrm>
+            <a:off x="228600" y="1005840"/>
+            <a:ext cx="6812280" cy="5440680"/>
+          </a:xfrm>
+          <a:prstGeom prst="rect">
+            <a:avLst/>
+          </a:prstGeom>
+          <a:solidFill>
+            <a:srgbClr val="F2F2F2"/>
+          </a:solidFill>
+          <a:ln>
+            <a:noFill/>
+          </a:ln>
+        </p:spPr>
+        <p:style>
+          <a:lnRef idx="1">
+            <a:schemeClr val="accent1"/>
+          </a:lnRef>
+          <a:fillRef idx="3">
+            <a:schemeClr val="accent1"/>
+          </a:fillRef>
+          <a:effectRef idx="2">
+            <a:schemeClr val="accent1"/>
+          </a:effectRef>
+          <a:fontRef idx="minor">
+            <a:schemeClr val="lt1"/>
+          </a:fontRef>
+        </p:style>
+        <p:txBody>
+          <a:bodyPr rtlCol="0" anchor="ctr"/>
+          <a:lstStyle/>
+          <a:p>
+            <a:pPr algn="ctr"/>
+          </a:p>
+        </p:txBody>
+      </p:sp>
+      <p:sp>
+        <p:nvSpPr>
+          <p:cNvPr id="11" name="Rectangle 10"/>
+          <p:cNvSpPr/>
+          <p:nvPr/>
+        </p:nvSpPr>
+        <p:spPr>
+          <a:xfrm>
+            <a:off x="228600" y="1005840"/>
+            <a:ext cx="6812280" cy="384048"/>
+          </a:xfrm>
+          <a:prstGeom prst="rect">
+            <a:avLst/>
+          </a:prstGeom>
+          <a:solidFill>
+            <a:srgbClr val="1A2E4A"/>
+          </a:solidFill>
+          <a:ln>
+            <a:noFill/>
+          </a:ln>
+        </p:spPr>
+        <p:style>
+          <a:lnRef idx="1">
+            <a:schemeClr val="accent1"/>
+          </a:lnRef>
+          <a:fillRef idx="3">
+            <a:schemeClr val="accent1"/>
+          </a:fillRef>
+          <a:effectRef idx="2">
+            <a:schemeClr val="accent1"/>
+          </a:effectRef>
+          <a:fontRef idx="minor">
+            <a:schemeClr val="lt1"/>
+          </a:fontRef>
+        </p:style>
+        <p:txBody>
+          <a:bodyPr rtlCol="0" anchor="ctr"/>
+          <a:lstStyle/>
+          <a:p>
+            <a:pPr algn="ctr"/>
+          </a:p>
+        </p:txBody>
+      </p:sp>
+      <p:sp>
+        <p:nvSpPr>
+          <p:cNvPr id="12" name="TextBox 11"/>
+          <p:cNvSpPr txBox="1"/>
+          <p:nvPr/>
+        </p:nvSpPr>
+        <p:spPr>
+          <a:xfrm>
+            <a:off x="228600" y="1005840"/>
+            <a:ext cx="6812280" cy="384048"/>
+          </a:xfrm>
+          <a:prstGeom prst="rect">
+            <a:avLst/>
+          </a:prstGeom>
+          <a:noFill/>
+        </p:spPr>
+        <p:txBody>
+          <a:bodyPr wrap="square">
+            <a:spAutoFit/>
+          </a:bodyPr>
+          <a:lstStyle/>
+          <a:p>
+            <a:pPr algn="ctr"/>
+            <a:r>
+              <a:rPr sz="1200" b="1">
+                <a:solidFill>
+                  <a:srgbClr val="FFFFFF"/>
+                </a:solidFill>
+                <a:latin typeface="맑은 고딕"/>
+              </a:rPr>
+              <a:t>픽킷코리아 (Pickit Korea)  —  발표 내용 요약</a:t>
+            </a:r>
+          </a:p>
+        </p:txBody>
+      </p:sp>
+      <p:sp>
+        <p:nvSpPr>
+          <p:cNvPr id="13" name="TextBox 12"/>
+          <p:cNvSpPr txBox="1"/>
+          <p:nvPr/>
+        </p:nvSpPr>
+        <p:spPr>
+          <a:xfrm>
+            <a:off x="347472" y="1444752"/>
+            <a:ext cx="6583680" cy="274320"/>
+          </a:xfrm>
+          <a:prstGeom prst="rect">
+            <a:avLst/>
+          </a:prstGeom>
+          <a:noFill/>
+        </p:spPr>
+        <p:txBody>
+          <a:bodyPr wrap="square">
+            <a:spAutoFit/>
+          </a:bodyPr>
+          <a:lstStyle/>
+          <a:p>
+            <a:pPr algn="l"/>
+            <a:r>
+              <a:rPr sz="1200" b="1">
+                <a:solidFill>
+                  <a:srgbClr val="1A2E4A"/>
+                </a:solidFill>
+                <a:latin typeface="맑은 고딕"/>
+              </a:rPr>
+              <a:t>■ 발표 주제</a:t>
+            </a:r>
+          </a:p>
+        </p:txBody>
+      </p:sp>
+      <p:sp>
+        <p:nvSpPr>
+          <p:cNvPr id="14" name="TextBox 13"/>
+          <p:cNvSpPr txBox="1"/>
+          <p:nvPr/>
+        </p:nvSpPr>
+        <p:spPr>
+          <a:xfrm>
+            <a:off x="347472" y="1719072"/>
+            <a:ext cx="6583680" cy="274320"/>
+          </a:xfrm>
+          <a:prstGeom prst="rect">
+            <a:avLst/>
+          </a:prstGeom>
+          <a:noFill/>
+        </p:spPr>
+        <p:txBody>
+          <a:bodyPr wrap="square">
+            <a:spAutoFit/>
+          </a:bodyPr>
+          <a:lstStyle/>
+          <a:p>
+            <a:pPr algn="l"/>
+            <a:r>
+              <a:rPr sz="1200" b="0">
+                <a:solidFill>
+                  <a:srgbClr val="1A1A1A"/>
+                </a:solidFill>
+                <a:latin typeface="맑은 고딕"/>
+              </a:rPr>
+              <a:t>AI 기반 3D Vision을 통한 자율제조(Autonomous Manufacturing)</a:t>
+            </a:r>
+          </a:p>
+        </p:txBody>
+      </p:sp>
+      <p:sp>
+        <p:nvSpPr>
+          <p:cNvPr id="15" name="TextBox 14"/>
+          <p:cNvSpPr txBox="1"/>
+          <p:nvPr/>
+        </p:nvSpPr>
+        <p:spPr>
+          <a:xfrm>
+            <a:off x="347472" y="2066543"/>
+            <a:ext cx="6583680" cy="274320"/>
+          </a:xfrm>
+          <a:prstGeom prst="rect">
+            <a:avLst/>
+          </a:prstGeom>
+          <a:noFill/>
+        </p:spPr>
+        <p:txBody>
+          <a:bodyPr wrap="square">
+            <a:spAutoFit/>
+          </a:bodyPr>
+          <a:lstStyle/>
+          <a:p>
+            <a:pPr algn="l"/>
+            <a:r>
+              <a:rPr sz="1200" b="1">
+                <a:solidFill>
+                  <a:srgbClr val="1A2E4A"/>
+                </a:solidFill>
+                <a:latin typeface="맑은 고딕"/>
+              </a:rPr>
+              <a:t>■ 핵심 발표 내용</a:t>
+            </a:r>
+          </a:p>
+        </p:txBody>
+      </p:sp>
+      <p:sp>
+        <p:nvSpPr>
+          <p:cNvPr id="16" name="TextBox 15"/>
+          <p:cNvSpPr txBox="1"/>
+          <p:nvPr/>
+        </p:nvSpPr>
+        <p:spPr>
+          <a:xfrm>
+            <a:off x="347472" y="2377440"/>
+            <a:ext cx="6583680" cy="1600200"/>
+          </a:xfrm>
+          <a:prstGeom prst="rect">
+            <a:avLst/>
+          </a:prstGeom>
+          <a:noFill/>
+        </p:spPr>
+        <p:txBody>
+          <a:bodyPr wrap="square">
+            <a:spAutoFit/>
+          </a:bodyPr>
+          <a:lstStyle/>
+          <a:p>
+            <a:pPr algn="l">
+              <a:spcAft>
+                <a:spcPts val="200"/>
+              </a:spcAft>
+            </a:pPr>
+            <a:r>
+              <a:rPr sz="1150" b="0">
+                <a:solidFill>
+                  <a:srgbClr val="1A1A1A"/>
+                </a:solidFill>
+                <a:latin typeface="맑은 고딕"/>
+              </a:rPr>
+              <a:t>• 랜덤 빈피킹(Bin Picking): 뒤섞인 부품을 3D 카메라로 위치·자세 인식 → 로봇 자율 파지</a:t>
+            </a:r>
+          </a:p>
+          <a:p>
+            <a:pPr algn="l">
+              <a:spcAft>
+                <a:spcPts val="200"/>
+              </a:spcAft>
+            </a:pPr>
+            <a:r>
+              <a:rPr sz="1150" b="0">
+                <a:solidFill>
+                  <a:srgbClr val="1A1A1A"/>
+                </a:solidFill>
+                <a:latin typeface="맑은 고딕"/>
+              </a:rPr>
+              <a:t>• No-Code AI 학습: 현장 인원이 새 부품을 소수 이미지만으로 등록, 재프로그래밍 불필요</a:t>
+            </a:r>
+          </a:p>
+          <a:p>
+            <a:pPr algn="l">
+              <a:spcAft>
+                <a:spcPts val="200"/>
+              </a:spcAft>
+            </a:pPr>
+            <a:r>
+              <a:rPr sz="1150" b="0">
+                <a:solidFill>
+                  <a:srgbClr val="1A1A1A"/>
+                </a:solidFill>
+                <a:latin typeface="맑은 고딕"/>
+              </a:rPr>
+              <a:t>• 적용 분야: 자동차 부품 조립 공급, 전자 부품 피킹, 식품·물류 소분 자동화</a:t>
+            </a:r>
+          </a:p>
+          <a:p>
+            <a:pPr algn="l">
+              <a:spcAft>
+                <a:spcPts val="200"/>
+              </a:spcAft>
+            </a:pPr>
+            <a:r>
+              <a:rPr sz="1150" b="0">
+                <a:solidFill>
+                  <a:srgbClr val="1A1A1A"/>
+                </a:solidFill>
+                <a:latin typeface="맑은 고딕"/>
+              </a:rPr>
+              <a:t>• 실증 성과: 수작업 대비 처리 속도 3배 향상, 비정형 부품 파지 성공률 98% 이상</a:t>
+            </a:r>
+          </a:p>
+          <a:p>
+            <a:pPr algn="l">
+              <a:spcAft>
+                <a:spcPts val="200"/>
+              </a:spcAft>
+            </a:pPr>
+            <a:r>
+              <a:rPr sz="1150" b="0">
+                <a:solidFill>
+                  <a:srgbClr val="1A1A1A"/>
+                </a:solidFill>
+                <a:latin typeface="맑은 고딕"/>
+              </a:rPr>
+              <a:t>• AI 비전 + 로봇 팔 완전 자율화 — 새 부품 학습 셋업 시간 30분 이내 달성</a:t>
+            </a:r>
+          </a:p>
+        </p:txBody>
+      </p:sp>
+      <p:sp>
+        <p:nvSpPr>
+          <p:cNvPr id="17" name="Rectangle 16"/>
+          <p:cNvSpPr/>
+          <p:nvPr/>
+        </p:nvSpPr>
+        <p:spPr>
+          <a:xfrm>
+            <a:off x="347472" y="4023360"/>
+            <a:ext cx="6583680" cy="27432"/>
+          </a:xfrm>
+          <a:prstGeom prst="rect">
+            <a:avLst/>
+          </a:prstGeom>
+          <a:solidFill>
+            <a:srgbClr val="CE0A2C"/>
+          </a:solidFill>
+          <a:ln>
+            <a:noFill/>
+          </a:ln>
+        </p:spPr>
+        <p:style>
+          <a:lnRef idx="1">
+            <a:schemeClr val="accent1"/>
+          </a:lnRef>
+          <a:fillRef idx="3">
+            <a:schemeClr val="accent1"/>
+          </a:fillRef>
+          <a:effectRef idx="2">
+            <a:schemeClr val="accent1"/>
+          </a:effectRef>
+          <a:fontRef idx="minor">
+            <a:schemeClr val="lt1"/>
+          </a:fontRef>
+        </p:style>
+        <p:txBody>
+          <a:bodyPr rtlCol="0" anchor="ctr"/>
+          <a:lstStyle/>
+          <a:p>
+            <a:pPr algn="ctr"/>
+          </a:p>
+        </p:txBody>
+      </p:sp>
+      <p:sp>
+        <p:nvSpPr>
+          <p:cNvPr id="18" name="TextBox 17"/>
+          <p:cNvSpPr txBox="1"/>
+          <p:nvPr/>
+        </p:nvSpPr>
+        <p:spPr>
+          <a:xfrm>
+            <a:off x="347472" y="4087368"/>
+            <a:ext cx="6583680" cy="274320"/>
+          </a:xfrm>
+          <a:prstGeom prst="rect">
+            <a:avLst/>
+          </a:prstGeom>
+          <a:noFill/>
+        </p:spPr>
+        <p:txBody>
+          <a:bodyPr wrap="square">
+            <a:spAutoFit/>
+          </a:bodyPr>
+          <a:lstStyle/>
+          <a:p>
+            <a:pPr algn="l"/>
+            <a:r>
+              <a:rPr sz="1200" b="1">
+                <a:solidFill>
+                  <a:srgbClr val="CE0A2C"/>
+                </a:solidFill>
+                <a:latin typeface="맑은 고딕"/>
+              </a:rPr>
+              <a:t>■ LG생산기술원 시사점</a:t>
+            </a:r>
+          </a:p>
+        </p:txBody>
+      </p:sp>
+      <p:sp>
+        <p:nvSpPr>
+          <p:cNvPr id="19" name="TextBox 18"/>
+          <p:cNvSpPr txBox="1"/>
+          <p:nvPr/>
+        </p:nvSpPr>
+        <p:spPr>
+          <a:xfrm>
+            <a:off x="347472" y="4407408"/>
+            <a:ext cx="6583680" cy="1005840"/>
+          </a:xfrm>
+          <a:prstGeom prst="rect">
+            <a:avLst/>
+          </a:prstGeom>
+          <a:noFill/>
+        </p:spPr>
+        <p:txBody>
+          <a:bodyPr wrap="square">
+            <a:spAutoFit/>
+          </a:bodyPr>
+          <a:lstStyle/>
+          <a:p>
+            <a:pPr algn="l">
+              <a:spcAft>
+                <a:spcPts val="200"/>
+              </a:spcAft>
+            </a:pPr>
+            <a:r>
+              <a:rPr sz="1100" b="0">
+                <a:solidFill>
+                  <a:srgbClr val="1A1A1A"/>
+                </a:solidFill>
+                <a:latin typeface="맑은 고딕"/>
+              </a:rPr>
+              <a:t>▶ 반도체 웨이퍼 이송 로봇(MM) 개발 시 3D 비전 통합 → 비정형 카세트 자율 파지 가능성</a:t>
+            </a:r>
+          </a:p>
+          <a:p>
+            <a:pPr algn="l">
+              <a:spcAft>
+                <a:spcPts val="200"/>
+              </a:spcAft>
+            </a:pPr>
+            <a:r>
+              <a:rPr sz="1100" b="0">
+                <a:solidFill>
+                  <a:srgbClr val="1A1A1A"/>
+                </a:solidFill>
+                <a:latin typeface="맑은 고딕"/>
+              </a:rPr>
+              <a:t>▶ 계열사 로보스타 차세대 AMR에 빈피킹 모듈 추가 시 고부가 자율 피킹 AMR 경쟁력 강화</a:t>
+            </a:r>
+          </a:p>
+          <a:p>
+            <a:pPr algn="l">
+              <a:spcAft>
+                <a:spcPts val="200"/>
+              </a:spcAft>
+            </a:pPr>
+            <a:r>
+              <a:rPr sz="1100" b="0">
+                <a:solidFill>
+                  <a:srgbClr val="1A1A1A"/>
+                </a:solidFill>
+                <a:latin typeface="맑은 고딕"/>
+              </a:rPr>
+              <a:t>▶ LG 생산라인 소부품 공급 공정: No-Code 방식으로 현장 운영자가 직접 운용 → 도입 장벽↓</a:t>
+            </a:r>
+          </a:p>
+        </p:txBody>
+      </p:sp>
+      <p:pic>
+        <p:nvPicPr>
+          <p:cNvPr id="20" name="Picture 19" descr="image.png"/>
+          <p:cNvPicPr>
+            <a:picLocks noChangeAspect="1"/>
+          </p:cNvPicPr>
+          <p:nvPr/>
+        </p:nvPicPr>
+        <p:blipFill>
+          <a:blip r:embed="rId2"/>
+          <a:stretch>
+            <a:fillRect/>
+          </a:stretch>
+        </p:blipFill>
+        <p:spPr>
+          <a:xfrm>
+            <a:off x="7223760" y="1005840"/>
+            <a:ext cx="4736592" cy="2926080"/>
+          </a:xfrm>
+          <a:prstGeom prst="rect">
+            <a:avLst/>
+          </a:prstGeom>
+        </p:spPr>
+      </p:pic>
+      <p:sp>
+        <p:nvSpPr>
+          <p:cNvPr id="21" name="TextBox 20"/>
+          <p:cNvSpPr txBox="1"/>
+          <p:nvPr/>
+        </p:nvSpPr>
+        <p:spPr>
+          <a:xfrm>
+            <a:off x="7223760" y="3977639"/>
+            <a:ext cx="4736592" cy="274320"/>
+          </a:xfrm>
+          <a:prstGeom prst="rect">
+            <a:avLst/>
+          </a:prstGeom>
+          <a:noFill/>
+        </p:spPr>
+        <p:txBody>
+          <a:bodyPr wrap="square">
+            <a:spAutoFit/>
+          </a:bodyPr>
+          <a:lstStyle/>
+          <a:p>
+            <a:pPr algn="ctr"/>
+            <a:r>
+              <a:rPr sz="950" b="0">
+                <a:solidFill>
+                  <a:srgbClr val="555555"/>
+                </a:solidFill>
+                <a:latin typeface="맑은 고딕"/>
+              </a:rPr>
+              <a:t>▲ AI 3D 비전 빈피킹 개념도 — 3D 카메라·AI·로봇의 자율 협업</a:t>
+            </a:r>
+          </a:p>
+        </p:txBody>
+      </p:sp>
+      <p:sp>
+        <p:nvSpPr>
+          <p:cNvPr id="22" name="Rectangle 21"/>
+          <p:cNvSpPr/>
+          <p:nvPr/>
+        </p:nvSpPr>
+        <p:spPr>
+          <a:xfrm>
+            <a:off x="7223760" y="4251960"/>
+            <a:ext cx="4736592" cy="2121408"/>
+          </a:xfrm>
+          <a:prstGeom prst="rect">
+            <a:avLst/>
+          </a:prstGeom>
+          <a:solidFill>
+            <a:srgbClr val="F2F2F2"/>
+          </a:solidFill>
+          <a:ln>
+            <a:noFill/>
+          </a:ln>
+        </p:spPr>
+        <p:style>
+          <a:lnRef idx="1">
+            <a:schemeClr val="accent1"/>
+          </a:lnRef>
+          <a:fillRef idx="3">
+            <a:schemeClr val="accent1"/>
+          </a:fillRef>
+          <a:effectRef idx="2">
+            <a:schemeClr val="accent1"/>
+          </a:effectRef>
+          <a:fontRef idx="minor">
+            <a:schemeClr val="lt1"/>
+          </a:fontRef>
+        </p:style>
+        <p:txBody>
+          <a:bodyPr rtlCol="0" anchor="ctr"/>
+          <a:lstStyle/>
+          <a:p>
+            <a:pPr algn="ctr"/>
+          </a:p>
+        </p:txBody>
+      </p:sp>
+      <p:sp>
+        <p:nvSpPr>
+          <p:cNvPr id="23" name="Rectangle 22"/>
+          <p:cNvSpPr/>
+          <p:nvPr/>
+        </p:nvSpPr>
+        <p:spPr>
+          <a:xfrm>
+            <a:off x="7223760" y="4251960"/>
+            <a:ext cx="45720" cy="2121408"/>
+          </a:xfrm>
+          <a:prstGeom prst="rect">
+            <a:avLst/>
+          </a:prstGeom>
+          <a:solidFill>
+            <a:srgbClr val="CE0A2C"/>
+          </a:solidFill>
+          <a:ln>
+            <a:noFill/>
+          </a:ln>
+        </p:spPr>
+        <p:style>
+          <a:lnRef idx="1">
+            <a:schemeClr val="accent1"/>
+          </a:lnRef>
+          <a:fillRef idx="3">
+            <a:schemeClr val="accent1"/>
+          </a:fillRef>
+          <a:effectRef idx="2">
+            <a:schemeClr val="accent1"/>
+          </a:effectRef>
+          <a:fontRef idx="minor">
+            <a:schemeClr val="lt1"/>
+          </a:fontRef>
+        </p:style>
+        <p:txBody>
+          <a:bodyPr rtlCol="0" anchor="ctr"/>
+          <a:lstStyle/>
+          <a:p>
+            <a:pPr algn="ctr"/>
+          </a:p>
+        </p:txBody>
+      </p:sp>
+      <p:sp>
+        <p:nvSpPr>
+          <p:cNvPr id="24" name="TextBox 23"/>
+          <p:cNvSpPr txBox="1"/>
+          <p:nvPr/>
+        </p:nvSpPr>
+        <p:spPr>
+          <a:xfrm>
+            <a:off x="7315200" y="4297680"/>
+            <a:ext cx="4572000" cy="2011680"/>
+          </a:xfrm>
+          <a:prstGeom prst="rect">
+            <a:avLst/>
+          </a:prstGeom>
+          <a:noFill/>
+        </p:spPr>
+        <p:txBody>
+          <a:bodyPr wrap="square">
+            <a:spAutoFit/>
+          </a:bodyPr>
+          <a:lstStyle/>
+          <a:p>
+            <a:pPr algn="l">
+              <a:spcAft>
+                <a:spcPts val="200"/>
+              </a:spcAft>
+            </a:pPr>
+            <a:r>
+              <a:rPr sz="1100" b="0">
+                <a:solidFill>
+                  <a:srgbClr val="1A1A1A"/>
+                </a:solidFill>
+                <a:latin typeface="맑은 고딕"/>
+              </a:rPr>
+              <a:t>적용 분야별 주요 사례</a:t>
+            </a:r>
+          </a:p>
+          <a:p>
+            <a:pPr algn="l">
+              <a:spcAft>
+                <a:spcPts val="200"/>
+              </a:spcAft>
+            </a:pPr>
+            <a:r>
+              <a:rPr sz="1100" b="0">
+                <a:solidFill>
+                  <a:srgbClr val="1A1A1A"/>
+                </a:solidFill>
+                <a:latin typeface="맑은 고딕"/>
+              </a:rPr>
+              <a:t>• 자동차: 엔진 부품·도어패널 공급 공정 (OEM 3곳 레퍼런스)</a:t>
+            </a:r>
+          </a:p>
+          <a:p>
+            <a:pPr algn="l">
+              <a:spcAft>
+                <a:spcPts val="200"/>
+              </a:spcAft>
+            </a:pPr>
+            <a:r>
+              <a:rPr sz="1100" b="0">
+                <a:solidFill>
+                  <a:srgbClr val="1A1A1A"/>
+                </a:solidFill>
+                <a:latin typeface="맑은 고딕"/>
+              </a:rPr>
+              <a:t>• 전자: PCB·커넥터 소형 부품 피킹 라인</a:t>
+            </a:r>
+          </a:p>
+          <a:p>
+            <a:pPr algn="l">
+              <a:spcAft>
+                <a:spcPts val="200"/>
+              </a:spcAft>
+            </a:pPr>
+            <a:r>
+              <a:rPr sz="1100" b="0">
+                <a:solidFill>
+                  <a:srgbClr val="1A1A1A"/>
+                </a:solidFill>
+                <a:latin typeface="맑은 고딕"/>
+              </a:rPr>
+              <a:t>• 물류: 혼재 박스 디팔레타이징 자동화</a:t>
+            </a:r>
+          </a:p>
+          <a:p>
+            <a:pPr algn="l">
+              <a:spcAft>
+                <a:spcPts val="200"/>
+              </a:spcAft>
+            </a:pPr>
+            <a:r>
+              <a:rPr sz="1100" b="0">
+                <a:solidFill>
+                  <a:srgbClr val="1A1A1A"/>
+                </a:solidFill>
+                <a:latin typeface="맑은 고딕"/>
+              </a:rPr>
+              <a:t>• 식품: 불규칙 형태 제품 포장 공정</a:t>
             </a:r>
           </a:p>
         </p:txBody>

</xml_diff>